<commit_message>
deck(s1-cl3): rebuild Topic 01 slides
Regenerated Topic 01 deck from committed source. Content verified correct.

Co-Authored-By: Claude Opus 4.8 (1M context) <noreply@anthropic.com>
</commit_message>
<xml_diff>
--- a/S1-CL3-Cloud-Infrastructure-Improvement/delivery/topic_01/Topic_01_Slides.pptx
+++ b/S1-CL3-Cloud-Infrastructure-Improvement/delivery/topic_01/Topic_01_Slides.pptx
@@ -4,26 +4,29 @@
   <p:sldMasterIdLst>
     <p:sldMasterId id="2147483648" r:id="rId1"/>
   </p:sldMasterIdLst>
+  <p:notesMasterIdLst>
+    <p:notesMasterId r:id="rId19"/>
+  </p:notesMasterIdLst>
   <p:sldIdLst>
-    <p:sldId id="256" r:id="rId7"/>
-    <p:sldId id="257" r:id="rId8"/>
-    <p:sldId id="258" r:id="rId10"/>
-    <p:sldId id="259" r:id="rId11"/>
-    <p:sldId id="260" r:id="rId12"/>
-    <p:sldId id="261" r:id="rId13"/>
-    <p:sldId id="262" r:id="rId14"/>
-    <p:sldId id="263" r:id="rId15"/>
-    <p:sldId id="264" r:id="rId16"/>
-    <p:sldId id="265" r:id="rId17"/>
-    <p:sldId id="266" r:id="rId18"/>
-    <p:sldId id="267" r:id="rId19"/>
-    <p:sldId id="268" r:id="rId20"/>
-    <p:sldId id="269" r:id="rId21"/>
-    <p:sldId id="270" r:id="rId22"/>
-    <p:sldId id="271" r:id="rId23"/>
-    <p:sldId id="272" r:id="rId24"/>
+    <p:sldId id="256" r:id="rId2"/>
+    <p:sldId id="257" r:id="rId3"/>
+    <p:sldId id="258" r:id="rId4"/>
+    <p:sldId id="259" r:id="rId5"/>
+    <p:sldId id="260" r:id="rId6"/>
+    <p:sldId id="261" r:id="rId7"/>
+    <p:sldId id="262" r:id="rId8"/>
+    <p:sldId id="263" r:id="rId9"/>
+    <p:sldId id="264" r:id="rId10"/>
+    <p:sldId id="265" r:id="rId11"/>
+    <p:sldId id="266" r:id="rId12"/>
+    <p:sldId id="267" r:id="rId13"/>
+    <p:sldId id="268" r:id="rId14"/>
+    <p:sldId id="269" r:id="rId15"/>
+    <p:sldId id="270" r:id="rId16"/>
+    <p:sldId id="271" r:id="rId17"/>
+    <p:sldId id="272" r:id="rId18"/>
   </p:sldIdLst>
-  <p:sldSz cx="12191695" cy="6858000" type="screen4x3"/>
+  <p:sldSz cx="12192000" cy="6858000"/>
   <p:notesSz cx="6858000" cy="9144000"/>
   <p:defaultTextStyle>
     <a:defPPr>
@@ -120,11 +123,27 @@
       </a:defRPr>
     </a:lvl9pPr>
   </p:defaultTextStyle>
+  <p:extLst>
+    <p:ext uri="{EFAFB233-063F-42B5-8137-9DF3F51BA10A}">
+      <p15:sldGuideLst xmlns:p15="http://schemas.microsoft.com/office/powerpoint/2012/main">
+        <p15:guide id="1" orient="horz" pos="2160">
+          <p15:clr>
+            <a:srgbClr val="A4A3A4"/>
+          </p15:clr>
+        </p15:guide>
+        <p15:guide id="2" pos="2880">
+          <p15:clr>
+            <a:srgbClr val="A4A3A4"/>
+          </p15:clr>
+        </p15:guide>
+      </p15:sldGuideLst>
+    </p:ext>
+  </p:extLst>
 </p:presentation>
 </file>
 
 <file path=ppt/notesMasters/notesMaster1.xml><?xml version="1.0" encoding="utf-8"?>
-<p:notesMaster xmlns:a="http://schemas.openxmlformats.org/drawingml/2006/main" xmlns:p="http://schemas.openxmlformats.org/presentationml/2006/main" xmlns:r="http://schemas.openxmlformats.org/officeDocument/2006/relationships">
+<p:notesMaster xmlns:a="http://schemas.openxmlformats.org/drawingml/2006/main" xmlns:r="http://schemas.openxmlformats.org/officeDocument/2006/relationships" xmlns:p="http://schemas.openxmlformats.org/presentationml/2006/main">
   <p:cSld>
     <p:bg>
       <p:bgRef idx="1001">
@@ -158,7 +177,7 @@
         <p:spPr>
           <a:xfrm>
             <a:off x="0" y="0"/>
-            <a:ext cx="2971800" cy="457200"/>
+            <a:ext cx="2971800" cy="458788"/>
           </a:xfrm>
           <a:prstGeom prst="rect">
             <a:avLst/>
@@ -189,7 +208,7 @@
         <p:spPr>
           <a:xfrm>
             <a:off x="3884613" y="0"/>
-            <a:ext cx="2971800" cy="457200"/>
+            <a:ext cx="2971800" cy="458788"/>
           </a:xfrm>
           <a:prstGeom prst="rect">
             <a:avLst/>
@@ -203,9 +222,9 @@
             </a:lvl1pPr>
           </a:lstStyle>
           <a:p>
-            <a:fld id="{0F89C1C7-3DCD-1040-A9CF-14679D8B5DDD}" type="datetimeFigureOut">
+            <a:fld id="{81DD04AB-B2DC-2C44-9147-3918CC5D531E}" type="datetimeFigureOut">
               <a:rPr lang="en-US" smtClean="0"/>
-              <a:t>10/17/16</a:t>
+              <a:t>7/9/26</a:t>
             </a:fld>
             <a:endParaRPr lang="en-US"/>
           </a:p>
@@ -223,8 +242,8 @@
         </p:nvSpPr>
         <p:spPr>
           <a:xfrm>
-            <a:off x="1143000" y="685800"/>
-            <a:ext cx="4572000" cy="3429000"/>
+            <a:off x="685800" y="1143000"/>
+            <a:ext cx="5486400" cy="3086100"/>
           </a:xfrm>
           <a:prstGeom prst="rect">
             <a:avLst/>
@@ -256,8 +275,8 @@
         </p:nvSpPr>
         <p:spPr>
           <a:xfrm>
-            <a:off x="685800" y="4343400"/>
-            <a:ext cx="5486400" cy="4114800"/>
+            <a:off x="685800" y="4400550"/>
+            <a:ext cx="5486400" cy="3600450"/>
           </a:xfrm>
           <a:prstGeom prst="rect">
             <a:avLst/>
@@ -269,35 +288,35 @@
           <a:p>
             <a:pPr lvl="0"/>
             <a:r>
-              <a:rPr lang="en-US" smtClean="0"/>
+              <a:rPr lang="en-GB"/>
               <a:t>Click to edit Master text styles</a:t>
             </a:r>
           </a:p>
           <a:p>
             <a:pPr lvl="1"/>
             <a:r>
-              <a:rPr lang="en-US" smtClean="0"/>
+              <a:rPr lang="en-GB"/>
               <a:t>Second level</a:t>
             </a:r>
           </a:p>
           <a:p>
             <a:pPr lvl="2"/>
             <a:r>
-              <a:rPr lang="en-US" smtClean="0"/>
+              <a:rPr lang="en-GB"/>
               <a:t>Third level</a:t>
             </a:r>
           </a:p>
           <a:p>
             <a:pPr lvl="3"/>
             <a:r>
-              <a:rPr lang="en-US" smtClean="0"/>
+              <a:rPr lang="en-GB"/>
               <a:t>Fourth level</a:t>
             </a:r>
           </a:p>
           <a:p>
             <a:pPr lvl="4"/>
             <a:r>
-              <a:rPr lang="en-US" smtClean="0"/>
+              <a:rPr lang="en-GB"/>
               <a:t>Fifth level</a:t>
             </a:r>
             <a:endParaRPr lang="en-US"/>
@@ -317,7 +336,7 @@
         <p:spPr>
           <a:xfrm>
             <a:off x="0" y="8685213"/>
-            <a:ext cx="2971800" cy="457200"/>
+            <a:ext cx="2971800" cy="458787"/>
           </a:xfrm>
           <a:prstGeom prst="rect">
             <a:avLst/>
@@ -348,7 +367,7 @@
         <p:spPr>
           <a:xfrm>
             <a:off x="3884613" y="8685213"/>
-            <a:ext cx="2971800" cy="457200"/>
+            <a:ext cx="2971800" cy="458787"/>
           </a:xfrm>
           <a:prstGeom prst="rect">
             <a:avLst/>
@@ -362,7 +381,7 @@
             </a:lvl1pPr>
           </a:lstStyle>
           <a:p>
-            <a:fld id="{BB5E49A5-4136-284D-997B-48E1D791AD67}" type="slidenum">
+            <a:fld id="{5E83A831-8944-C345-861C-1D0BDE2110C0}" type="slidenum">
               <a:rPr lang="en-US" smtClean="0"/>
               <a:t>‹#›</a:t>
             </a:fld>
@@ -373,13 +392,13 @@
     </p:spTree>
     <p:extLst>
       <p:ext uri="{BB962C8B-B14F-4D97-AF65-F5344CB8AC3E}">
-        <p14:creationId xmlns:p14="http://schemas.microsoft.com/office/powerpoint/2010/main" val="2623252185"/>
+        <p14:creationId xmlns:p14="http://schemas.microsoft.com/office/powerpoint/2010/main" val="2729961678"/>
       </p:ext>
     </p:extLst>
   </p:cSld>
   <p:clrMap bg1="lt1" tx1="dk1" bg2="lt2" tx2="dk2" accent1="accent1" accent2="accent2" accent3="accent3" accent4="accent4" accent5="accent5" accent6="accent6" hlink="hlink" folHlink="folHlink"/>
   <p:notesStyle>
-    <a:lvl1pPr marL="0" algn="l" defTabSz="457200" rtl="0" eaLnBrk="1" latinLnBrk="0" hangingPunct="1">
+    <a:lvl1pPr marL="0" algn="l" defTabSz="914400" rtl="0" eaLnBrk="1" latinLnBrk="0" hangingPunct="1">
       <a:defRPr sz="1200" kern="1200">
         <a:solidFill>
           <a:schemeClr val="tx1"/>
@@ -389,7 +408,7 @@
         <a:cs typeface="+mn-cs"/>
       </a:defRPr>
     </a:lvl1pPr>
-    <a:lvl2pPr marL="457200" algn="l" defTabSz="457200" rtl="0" eaLnBrk="1" latinLnBrk="0" hangingPunct="1">
+    <a:lvl2pPr marL="457200" algn="l" defTabSz="914400" rtl="0" eaLnBrk="1" latinLnBrk="0" hangingPunct="1">
       <a:defRPr sz="1200" kern="1200">
         <a:solidFill>
           <a:schemeClr val="tx1"/>
@@ -399,7 +418,7 @@
         <a:cs typeface="+mn-cs"/>
       </a:defRPr>
     </a:lvl2pPr>
-    <a:lvl3pPr marL="914400" algn="l" defTabSz="457200" rtl="0" eaLnBrk="1" latinLnBrk="0" hangingPunct="1">
+    <a:lvl3pPr marL="914400" algn="l" defTabSz="914400" rtl="0" eaLnBrk="1" latinLnBrk="0" hangingPunct="1">
       <a:defRPr sz="1200" kern="1200">
         <a:solidFill>
           <a:schemeClr val="tx1"/>
@@ -409,7 +428,7 @@
         <a:cs typeface="+mn-cs"/>
       </a:defRPr>
     </a:lvl3pPr>
-    <a:lvl4pPr marL="1371600" algn="l" defTabSz="457200" rtl="0" eaLnBrk="1" latinLnBrk="0" hangingPunct="1">
+    <a:lvl4pPr marL="1371600" algn="l" defTabSz="914400" rtl="0" eaLnBrk="1" latinLnBrk="0" hangingPunct="1">
       <a:defRPr sz="1200" kern="1200">
         <a:solidFill>
           <a:schemeClr val="tx1"/>
@@ -419,7 +438,7 @@
         <a:cs typeface="+mn-cs"/>
       </a:defRPr>
     </a:lvl4pPr>
-    <a:lvl5pPr marL="1828800" algn="l" defTabSz="457200" rtl="0" eaLnBrk="1" latinLnBrk="0" hangingPunct="1">
+    <a:lvl5pPr marL="1828800" algn="l" defTabSz="914400" rtl="0" eaLnBrk="1" latinLnBrk="0" hangingPunct="1">
       <a:defRPr sz="1200" kern="1200">
         <a:solidFill>
           <a:schemeClr val="tx1"/>
@@ -429,7 +448,7 @@
         <a:cs typeface="+mn-cs"/>
       </a:defRPr>
     </a:lvl5pPr>
-    <a:lvl6pPr marL="2286000" algn="l" defTabSz="457200" rtl="0" eaLnBrk="1" latinLnBrk="0" hangingPunct="1">
+    <a:lvl6pPr marL="2286000" algn="l" defTabSz="914400" rtl="0" eaLnBrk="1" latinLnBrk="0" hangingPunct="1">
       <a:defRPr sz="1200" kern="1200">
         <a:solidFill>
           <a:schemeClr val="tx1"/>
@@ -439,7 +458,7 @@
         <a:cs typeface="+mn-cs"/>
       </a:defRPr>
     </a:lvl6pPr>
-    <a:lvl7pPr marL="2743200" algn="l" defTabSz="457200" rtl="0" eaLnBrk="1" latinLnBrk="0" hangingPunct="1">
+    <a:lvl7pPr marL="2743200" algn="l" defTabSz="914400" rtl="0" eaLnBrk="1" latinLnBrk="0" hangingPunct="1">
       <a:defRPr sz="1200" kern="1200">
         <a:solidFill>
           <a:schemeClr val="tx1"/>
@@ -449,7 +468,7 @@
         <a:cs typeface="+mn-cs"/>
       </a:defRPr>
     </a:lvl7pPr>
-    <a:lvl8pPr marL="3200400" algn="l" defTabSz="457200" rtl="0" eaLnBrk="1" latinLnBrk="0" hangingPunct="1">
+    <a:lvl8pPr marL="3200400" algn="l" defTabSz="914400" rtl="0" eaLnBrk="1" latinLnBrk="0" hangingPunct="1">
       <a:defRPr sz="1200" kern="1200">
         <a:solidFill>
           <a:schemeClr val="tx1"/>
@@ -459,7 +478,7 @@
         <a:cs typeface="+mn-cs"/>
       </a:defRPr>
     </a:lvl8pPr>
-    <a:lvl9pPr marL="3657600" algn="l" defTabSz="457200" rtl="0" eaLnBrk="1" latinLnBrk="0" hangingPunct="1">
+    <a:lvl9pPr marL="3657600" algn="l" defTabSz="914400" rtl="0" eaLnBrk="1" latinLnBrk="0" hangingPunct="1">
       <a:defRPr sz="1200" kern="1200">
         <a:solidFill>
           <a:schemeClr val="tx1"/>
@@ -474,7 +493,7 @@
 </file>
 
 <file path=ppt/notesSlides/notesSlide1.xml><?xml version="1.0" encoding="utf-8"?>
-<p:notes xmlns:a="http://schemas.openxmlformats.org/drawingml/2006/main" xmlns:p="http://schemas.openxmlformats.org/presentationml/2006/main" xmlns:r="http://schemas.openxmlformats.org/officeDocument/2006/relationships">
+<p:notes xmlns:a="http://schemas.openxmlformats.org/drawingml/2006/main" xmlns:r="http://schemas.openxmlformats.org/officeDocument/2006/relationships" xmlns:p="http://schemas.openxmlformats.org/presentationml/2006/main">
   <p:cSld>
     <p:spTree>
       <p:nvGrpSpPr>
@@ -494,7 +513,7 @@
         <p:nvSpPr>
           <p:cNvPr id="2" name="Slide Image Placeholder 1"/>
           <p:cNvSpPr>
-            <a:spLocks noGrp="1"/>
+            <a:spLocks noGrp="1" noRot="1" noChangeAspect="1"/>
           </p:cNvSpPr>
           <p:nvPr>
             <p:ph type="sldImg" idx="2"/>
@@ -509,7 +528,7 @@
             <a:spLocks noGrp="1"/>
           </p:cNvSpPr>
           <p:nvPr>
-            <p:ph type="body" idx="3" sz="quarter"/>
+            <p:ph type="body" sz="quarter" idx="3"/>
           </p:nvPr>
         </p:nvSpPr>
         <p:spPr/>
@@ -605,7 +624,7 @@
             <a:spLocks noGrp="1"/>
           </p:cNvSpPr>
           <p:nvPr>
-            <p:ph type="sldNum" idx="5" sz="quarter"/>
+            <p:ph type="sldNum" sz="quarter" idx="5"/>
           </p:nvPr>
         </p:nvSpPr>
         <p:spPr/>
@@ -619,7 +638,7 @@
 </file>
 
 <file path=ppt/notesSlides/notesSlide10.xml><?xml version="1.0" encoding="utf-8"?>
-<p:notes xmlns:a="http://schemas.openxmlformats.org/drawingml/2006/main" xmlns:p="http://schemas.openxmlformats.org/presentationml/2006/main" xmlns:r="http://schemas.openxmlformats.org/officeDocument/2006/relationships">
+<p:notes xmlns:a="http://schemas.openxmlformats.org/drawingml/2006/main" xmlns:r="http://schemas.openxmlformats.org/officeDocument/2006/relationships" xmlns:p="http://schemas.openxmlformats.org/presentationml/2006/main">
   <p:cSld>
     <p:spTree>
       <p:nvGrpSpPr>
@@ -639,7 +658,7 @@
         <p:nvSpPr>
           <p:cNvPr id="2" name="Slide Image Placeholder 1"/>
           <p:cNvSpPr>
-            <a:spLocks noGrp="1"/>
+            <a:spLocks noGrp="1" noRot="1" noChangeAspect="1"/>
           </p:cNvSpPr>
           <p:nvPr>
             <p:ph type="sldImg" idx="2"/>
@@ -654,7 +673,7 @@
             <a:spLocks noGrp="1"/>
           </p:cNvSpPr>
           <p:nvPr>
-            <p:ph type="body" idx="3" sz="quarter"/>
+            <p:ph type="body" sz="quarter" idx="3"/>
           </p:nvPr>
         </p:nvSpPr>
         <p:spPr/>
@@ -745,7 +764,7 @@
             <a:spLocks noGrp="1"/>
           </p:cNvSpPr>
           <p:nvPr>
-            <p:ph type="sldNum" idx="5" sz="quarter"/>
+            <p:ph type="sldNum" sz="quarter" idx="5"/>
           </p:nvPr>
         </p:nvSpPr>
         <p:spPr/>
@@ -759,7 +778,7 @@
 </file>
 
 <file path=ppt/notesSlides/notesSlide11.xml><?xml version="1.0" encoding="utf-8"?>
-<p:notes xmlns:a="http://schemas.openxmlformats.org/drawingml/2006/main" xmlns:p="http://schemas.openxmlformats.org/presentationml/2006/main" xmlns:r="http://schemas.openxmlformats.org/officeDocument/2006/relationships">
+<p:notes xmlns:a="http://schemas.openxmlformats.org/drawingml/2006/main" xmlns:r="http://schemas.openxmlformats.org/officeDocument/2006/relationships" xmlns:p="http://schemas.openxmlformats.org/presentationml/2006/main">
   <p:cSld>
     <p:spTree>
       <p:nvGrpSpPr>
@@ -779,7 +798,7 @@
         <p:nvSpPr>
           <p:cNvPr id="2" name="Slide Image Placeholder 1"/>
           <p:cNvSpPr>
-            <a:spLocks noGrp="1"/>
+            <a:spLocks noGrp="1" noRot="1" noChangeAspect="1"/>
           </p:cNvSpPr>
           <p:nvPr>
             <p:ph type="sldImg" idx="2"/>
@@ -794,7 +813,7 @@
             <a:spLocks noGrp="1"/>
           </p:cNvSpPr>
           <p:nvPr>
-            <p:ph type="body" idx="3" sz="quarter"/>
+            <p:ph type="body" sz="quarter" idx="3"/>
           </p:nvPr>
         </p:nvSpPr>
         <p:spPr/>
@@ -895,7 +914,7 @@
             <a:spLocks noGrp="1"/>
           </p:cNvSpPr>
           <p:nvPr>
-            <p:ph type="sldNum" idx="5" sz="quarter"/>
+            <p:ph type="sldNum" sz="quarter" idx="5"/>
           </p:nvPr>
         </p:nvSpPr>
         <p:spPr/>
@@ -909,7 +928,7 @@
 </file>
 
 <file path=ppt/notesSlides/notesSlide2.xml><?xml version="1.0" encoding="utf-8"?>
-<p:notes xmlns:a="http://schemas.openxmlformats.org/drawingml/2006/main" xmlns:p="http://schemas.openxmlformats.org/presentationml/2006/main" xmlns:r="http://schemas.openxmlformats.org/officeDocument/2006/relationships">
+<p:notes xmlns:a="http://schemas.openxmlformats.org/drawingml/2006/main" xmlns:r="http://schemas.openxmlformats.org/officeDocument/2006/relationships" xmlns:p="http://schemas.openxmlformats.org/presentationml/2006/main">
   <p:cSld>
     <p:spTree>
       <p:nvGrpSpPr>
@@ -929,7 +948,7 @@
         <p:nvSpPr>
           <p:cNvPr id="2" name="Slide Image Placeholder 1"/>
           <p:cNvSpPr>
-            <a:spLocks noGrp="1"/>
+            <a:spLocks noGrp="1" noRot="1" noChangeAspect="1"/>
           </p:cNvSpPr>
           <p:nvPr>
             <p:ph type="sldImg" idx="2"/>
@@ -944,7 +963,7 @@
             <a:spLocks noGrp="1"/>
           </p:cNvSpPr>
           <p:nvPr>
-            <p:ph type="body" idx="3" sz="quarter"/>
+            <p:ph type="body" sz="quarter" idx="3"/>
           </p:nvPr>
         </p:nvSpPr>
         <p:spPr/>
@@ -1035,7 +1054,7 @@
             <a:spLocks noGrp="1"/>
           </p:cNvSpPr>
           <p:nvPr>
-            <p:ph type="sldNum" idx="5" sz="quarter"/>
+            <p:ph type="sldNum" sz="quarter" idx="5"/>
           </p:nvPr>
         </p:nvSpPr>
         <p:spPr/>
@@ -1049,7 +1068,7 @@
 </file>
 
 <file path=ppt/notesSlides/notesSlide3.xml><?xml version="1.0" encoding="utf-8"?>
-<p:notes xmlns:a="http://schemas.openxmlformats.org/drawingml/2006/main" xmlns:p="http://schemas.openxmlformats.org/presentationml/2006/main" xmlns:r="http://schemas.openxmlformats.org/officeDocument/2006/relationships">
+<p:notes xmlns:a="http://schemas.openxmlformats.org/drawingml/2006/main" xmlns:r="http://schemas.openxmlformats.org/officeDocument/2006/relationships" xmlns:p="http://schemas.openxmlformats.org/presentationml/2006/main">
   <p:cSld>
     <p:spTree>
       <p:nvGrpSpPr>
@@ -1069,7 +1088,7 @@
         <p:nvSpPr>
           <p:cNvPr id="2" name="Slide Image Placeholder 1"/>
           <p:cNvSpPr>
-            <a:spLocks noGrp="1"/>
+            <a:spLocks noGrp="1" noRot="1" noChangeAspect="1"/>
           </p:cNvSpPr>
           <p:nvPr>
             <p:ph type="sldImg" idx="2"/>
@@ -1084,7 +1103,7 @@
             <a:spLocks noGrp="1"/>
           </p:cNvSpPr>
           <p:nvPr>
-            <p:ph type="body" idx="3" sz="quarter"/>
+            <p:ph type="body" sz="quarter" idx="3"/>
           </p:nvPr>
         </p:nvSpPr>
         <p:spPr/>
@@ -1175,7 +1194,7 @@
             <a:spLocks noGrp="1"/>
           </p:cNvSpPr>
           <p:nvPr>
-            <p:ph type="sldNum" idx="5" sz="quarter"/>
+            <p:ph type="sldNum" sz="quarter" idx="5"/>
           </p:nvPr>
         </p:nvSpPr>
         <p:spPr/>
@@ -1189,7 +1208,7 @@
 </file>
 
 <file path=ppt/notesSlides/notesSlide4.xml><?xml version="1.0" encoding="utf-8"?>
-<p:notes xmlns:a="http://schemas.openxmlformats.org/drawingml/2006/main" xmlns:p="http://schemas.openxmlformats.org/presentationml/2006/main" xmlns:r="http://schemas.openxmlformats.org/officeDocument/2006/relationships">
+<p:notes xmlns:a="http://schemas.openxmlformats.org/drawingml/2006/main" xmlns:r="http://schemas.openxmlformats.org/officeDocument/2006/relationships" xmlns:p="http://schemas.openxmlformats.org/presentationml/2006/main">
   <p:cSld>
     <p:spTree>
       <p:nvGrpSpPr>
@@ -1209,7 +1228,7 @@
         <p:nvSpPr>
           <p:cNvPr id="2" name="Slide Image Placeholder 1"/>
           <p:cNvSpPr>
-            <a:spLocks noGrp="1"/>
+            <a:spLocks noGrp="1" noRot="1" noChangeAspect="1"/>
           </p:cNvSpPr>
           <p:nvPr>
             <p:ph type="sldImg" idx="2"/>
@@ -1224,7 +1243,7 @@
             <a:spLocks noGrp="1"/>
           </p:cNvSpPr>
           <p:nvPr>
-            <p:ph type="body" idx="3" sz="quarter"/>
+            <p:ph type="body" sz="quarter" idx="3"/>
           </p:nvPr>
         </p:nvSpPr>
         <p:spPr/>
@@ -1315,7 +1334,7 @@
             <a:spLocks noGrp="1"/>
           </p:cNvSpPr>
           <p:nvPr>
-            <p:ph type="sldNum" idx="5" sz="quarter"/>
+            <p:ph type="sldNum" sz="quarter" idx="5"/>
           </p:nvPr>
         </p:nvSpPr>
         <p:spPr/>
@@ -1329,7 +1348,7 @@
 </file>
 
 <file path=ppt/notesSlides/notesSlide5.xml><?xml version="1.0" encoding="utf-8"?>
-<p:notes xmlns:a="http://schemas.openxmlformats.org/drawingml/2006/main" xmlns:p="http://schemas.openxmlformats.org/presentationml/2006/main" xmlns:r="http://schemas.openxmlformats.org/officeDocument/2006/relationships">
+<p:notes xmlns:a="http://schemas.openxmlformats.org/drawingml/2006/main" xmlns:r="http://schemas.openxmlformats.org/officeDocument/2006/relationships" xmlns:p="http://schemas.openxmlformats.org/presentationml/2006/main">
   <p:cSld>
     <p:spTree>
       <p:nvGrpSpPr>
@@ -1349,7 +1368,7 @@
         <p:nvSpPr>
           <p:cNvPr id="2" name="Slide Image Placeholder 1"/>
           <p:cNvSpPr>
-            <a:spLocks noGrp="1"/>
+            <a:spLocks noGrp="1" noRot="1" noChangeAspect="1"/>
           </p:cNvSpPr>
           <p:nvPr>
             <p:ph type="sldImg" idx="2"/>
@@ -1364,7 +1383,7 @@
             <a:spLocks noGrp="1"/>
           </p:cNvSpPr>
           <p:nvPr>
-            <p:ph type="body" idx="3" sz="quarter"/>
+            <p:ph type="body" sz="quarter" idx="3"/>
           </p:nvPr>
         </p:nvSpPr>
         <p:spPr/>
@@ -1470,7 +1489,7 @@
             <a:spLocks noGrp="1"/>
           </p:cNvSpPr>
           <p:nvPr>
-            <p:ph type="sldNum" idx="5" sz="quarter"/>
+            <p:ph type="sldNum" sz="quarter" idx="5"/>
           </p:nvPr>
         </p:nvSpPr>
         <p:spPr/>
@@ -1484,7 +1503,7 @@
 </file>
 
 <file path=ppt/notesSlides/notesSlide6.xml><?xml version="1.0" encoding="utf-8"?>
-<p:notes xmlns:a="http://schemas.openxmlformats.org/drawingml/2006/main" xmlns:p="http://schemas.openxmlformats.org/presentationml/2006/main" xmlns:r="http://schemas.openxmlformats.org/officeDocument/2006/relationships">
+<p:notes xmlns:a="http://schemas.openxmlformats.org/drawingml/2006/main" xmlns:r="http://schemas.openxmlformats.org/officeDocument/2006/relationships" xmlns:p="http://schemas.openxmlformats.org/presentationml/2006/main">
   <p:cSld>
     <p:spTree>
       <p:nvGrpSpPr>
@@ -1504,7 +1523,7 @@
         <p:nvSpPr>
           <p:cNvPr id="2" name="Slide Image Placeholder 1"/>
           <p:cNvSpPr>
-            <a:spLocks noGrp="1"/>
+            <a:spLocks noGrp="1" noRot="1" noChangeAspect="1"/>
           </p:cNvSpPr>
           <p:nvPr>
             <p:ph type="sldImg" idx="2"/>
@@ -1519,7 +1538,7 @@
             <a:spLocks noGrp="1"/>
           </p:cNvSpPr>
           <p:nvPr>
-            <p:ph type="body" idx="3" sz="quarter"/>
+            <p:ph type="body" sz="quarter" idx="3"/>
           </p:nvPr>
         </p:nvSpPr>
         <p:spPr/>
@@ -1605,7 +1624,7 @@
             <a:spLocks noGrp="1"/>
           </p:cNvSpPr>
           <p:nvPr>
-            <p:ph type="sldNum" idx="5" sz="quarter"/>
+            <p:ph type="sldNum" sz="quarter" idx="5"/>
           </p:nvPr>
         </p:nvSpPr>
         <p:spPr/>
@@ -1619,7 +1638,7 @@
 </file>
 
 <file path=ppt/notesSlides/notesSlide7.xml><?xml version="1.0" encoding="utf-8"?>
-<p:notes xmlns:a="http://schemas.openxmlformats.org/drawingml/2006/main" xmlns:p="http://schemas.openxmlformats.org/presentationml/2006/main" xmlns:r="http://schemas.openxmlformats.org/officeDocument/2006/relationships">
+<p:notes xmlns:a="http://schemas.openxmlformats.org/drawingml/2006/main" xmlns:r="http://schemas.openxmlformats.org/officeDocument/2006/relationships" xmlns:p="http://schemas.openxmlformats.org/presentationml/2006/main">
   <p:cSld>
     <p:spTree>
       <p:nvGrpSpPr>
@@ -1639,7 +1658,7 @@
         <p:nvSpPr>
           <p:cNvPr id="2" name="Slide Image Placeholder 1"/>
           <p:cNvSpPr>
-            <a:spLocks noGrp="1"/>
+            <a:spLocks noGrp="1" noRot="1" noChangeAspect="1"/>
           </p:cNvSpPr>
           <p:nvPr>
             <p:ph type="sldImg" idx="2"/>
@@ -1654,7 +1673,7 @@
             <a:spLocks noGrp="1"/>
           </p:cNvSpPr>
           <p:nvPr>
-            <p:ph type="body" idx="3" sz="quarter"/>
+            <p:ph type="body" sz="quarter" idx="3"/>
           </p:nvPr>
         </p:nvSpPr>
         <p:spPr/>
@@ -1745,7 +1764,7 @@
             <a:spLocks noGrp="1"/>
           </p:cNvSpPr>
           <p:nvPr>
-            <p:ph type="sldNum" idx="5" sz="quarter"/>
+            <p:ph type="sldNum" sz="quarter" idx="5"/>
           </p:nvPr>
         </p:nvSpPr>
         <p:spPr/>
@@ -1759,7 +1778,7 @@
 </file>
 
 <file path=ppt/notesSlides/notesSlide8.xml><?xml version="1.0" encoding="utf-8"?>
-<p:notes xmlns:a="http://schemas.openxmlformats.org/drawingml/2006/main" xmlns:p="http://schemas.openxmlformats.org/presentationml/2006/main" xmlns:r="http://schemas.openxmlformats.org/officeDocument/2006/relationships">
+<p:notes xmlns:a="http://schemas.openxmlformats.org/drawingml/2006/main" xmlns:r="http://schemas.openxmlformats.org/officeDocument/2006/relationships" xmlns:p="http://schemas.openxmlformats.org/presentationml/2006/main">
   <p:cSld>
     <p:spTree>
       <p:nvGrpSpPr>
@@ -1779,7 +1798,7 @@
         <p:nvSpPr>
           <p:cNvPr id="2" name="Slide Image Placeholder 1"/>
           <p:cNvSpPr>
-            <a:spLocks noGrp="1"/>
+            <a:spLocks noGrp="1" noRot="1" noChangeAspect="1"/>
           </p:cNvSpPr>
           <p:nvPr>
             <p:ph type="sldImg" idx="2"/>
@@ -1794,7 +1813,7 @@
             <a:spLocks noGrp="1"/>
           </p:cNvSpPr>
           <p:nvPr>
-            <p:ph type="body" idx="3" sz="quarter"/>
+            <p:ph type="body" sz="quarter" idx="3"/>
           </p:nvPr>
         </p:nvSpPr>
         <p:spPr/>
@@ -1895,7 +1914,7 @@
             <a:spLocks noGrp="1"/>
           </p:cNvSpPr>
           <p:nvPr>
-            <p:ph type="sldNum" idx="5" sz="quarter"/>
+            <p:ph type="sldNum" sz="quarter" idx="5"/>
           </p:nvPr>
         </p:nvSpPr>
         <p:spPr/>
@@ -1909,7 +1928,7 @@
 </file>
 
 <file path=ppt/notesSlides/notesSlide9.xml><?xml version="1.0" encoding="utf-8"?>
-<p:notes xmlns:a="http://schemas.openxmlformats.org/drawingml/2006/main" xmlns:p="http://schemas.openxmlformats.org/presentationml/2006/main" xmlns:r="http://schemas.openxmlformats.org/officeDocument/2006/relationships">
+<p:notes xmlns:a="http://schemas.openxmlformats.org/drawingml/2006/main" xmlns:r="http://schemas.openxmlformats.org/officeDocument/2006/relationships" xmlns:p="http://schemas.openxmlformats.org/presentationml/2006/main">
   <p:cSld>
     <p:spTree>
       <p:nvGrpSpPr>
@@ -1929,7 +1948,7 @@
         <p:nvSpPr>
           <p:cNvPr id="2" name="Slide Image Placeholder 1"/>
           <p:cNvSpPr>
-            <a:spLocks noGrp="1"/>
+            <a:spLocks noGrp="1" noRot="1" noChangeAspect="1"/>
           </p:cNvSpPr>
           <p:nvPr>
             <p:ph type="sldImg" idx="2"/>
@@ -1944,7 +1963,7 @@
             <a:spLocks noGrp="1"/>
           </p:cNvSpPr>
           <p:nvPr>
-            <p:ph type="body" idx="3" sz="quarter"/>
+            <p:ph type="body" sz="quarter" idx="3"/>
           </p:nvPr>
         </p:nvSpPr>
         <p:spPr/>
@@ -2030,7 +2049,7 @@
             <a:spLocks noGrp="1"/>
           </p:cNvSpPr>
           <p:nvPr>
-            <p:ph type="sldNum" idx="5" sz="quarter"/>
+            <p:ph type="sldNum" sz="quarter" idx="5"/>
           </p:nvPr>
         </p:nvSpPr>
         <p:spPr/>
@@ -2081,10 +2100,9 @@
           <a:lstStyle/>
           <a:p>
             <a:r>
-              <a:rPr lang="en-US" smtClean="0"/>
+              <a:rPr lang="en-US"/>
               <a:t>Click to edit Master title style</a:t>
             </a:r>
-            <a:endParaRPr lang="en-US"/>
           </a:p>
         </p:txBody>
       </p:sp>
@@ -2200,10 +2218,9 @@
           </a:lstStyle>
           <a:p>
             <a:r>
-              <a:rPr lang="en-US" smtClean="0"/>
+              <a:rPr lang="en-US"/>
               <a:t>Click to edit Master subtitle style</a:t>
             </a:r>
-            <a:endParaRPr lang="en-US"/>
           </a:p>
         </p:txBody>
       </p:sp>
@@ -2224,7 +2241,7 @@
           <a:p>
             <a:fld id="{5BCAD085-E8A6-8845-BD4E-CB4CCA059FC4}" type="datetimeFigureOut">
               <a:rPr lang="en-US" smtClean="0"/>
-              <a:t>1/27/13</a:t>
+              <a:t>7/9/26</a:t>
             </a:fld>
             <a:endParaRPr lang="en-US"/>
           </a:p>
@@ -2318,10 +2335,9 @@
           <a:lstStyle/>
           <a:p>
             <a:r>
-              <a:rPr lang="en-US" smtClean="0"/>
+              <a:rPr lang="en-US"/>
               <a:t>Click to edit Master title style</a:t>
             </a:r>
-            <a:endParaRPr lang="en-US"/>
           </a:p>
         </p:txBody>
       </p:sp>
@@ -2342,38 +2358,37 @@
           <a:p>
             <a:pPr lvl="0"/>
             <a:r>
-              <a:rPr lang="en-US" smtClean="0"/>
+              <a:rPr lang="en-US"/>
               <a:t>Click to edit Master text styles</a:t>
             </a:r>
           </a:p>
           <a:p>
             <a:pPr lvl="1"/>
             <a:r>
-              <a:rPr lang="en-US" smtClean="0"/>
+              <a:rPr lang="en-US"/>
               <a:t>Second level</a:t>
             </a:r>
           </a:p>
           <a:p>
             <a:pPr lvl="2"/>
             <a:r>
-              <a:rPr lang="en-US" smtClean="0"/>
+              <a:rPr lang="en-US"/>
               <a:t>Third level</a:t>
             </a:r>
           </a:p>
           <a:p>
             <a:pPr lvl="3"/>
             <a:r>
-              <a:rPr lang="en-US" smtClean="0"/>
+              <a:rPr lang="en-US"/>
               <a:t>Fourth level</a:t>
             </a:r>
           </a:p>
           <a:p>
             <a:pPr lvl="4"/>
             <a:r>
-              <a:rPr lang="en-US" smtClean="0"/>
+              <a:rPr lang="en-US"/>
               <a:t>Fifth level</a:t>
             </a:r>
-            <a:endParaRPr lang="en-US"/>
           </a:p>
         </p:txBody>
       </p:sp>
@@ -2394,7 +2409,7 @@
           <a:p>
             <a:fld id="{5BCAD085-E8A6-8845-BD4E-CB4CCA059FC4}" type="datetimeFigureOut">
               <a:rPr lang="en-US" smtClean="0"/>
-              <a:t>1/27/13</a:t>
+              <a:t>7/9/26</a:t>
             </a:fld>
             <a:endParaRPr lang="en-US"/>
           </a:p>
@@ -2493,10 +2508,9 @@
           <a:lstStyle/>
           <a:p>
             <a:r>
-              <a:rPr lang="en-US" smtClean="0"/>
+              <a:rPr lang="en-US"/>
               <a:t>Click to edit Master title style</a:t>
             </a:r>
-            <a:endParaRPr lang="en-US"/>
           </a:p>
         </p:txBody>
       </p:sp>
@@ -2522,38 +2536,37 @@
           <a:p>
             <a:pPr lvl="0"/>
             <a:r>
-              <a:rPr lang="en-US" smtClean="0"/>
+              <a:rPr lang="en-US"/>
               <a:t>Click to edit Master text styles</a:t>
             </a:r>
           </a:p>
           <a:p>
             <a:pPr lvl="1"/>
             <a:r>
-              <a:rPr lang="en-US" smtClean="0"/>
+              <a:rPr lang="en-US"/>
               <a:t>Second level</a:t>
             </a:r>
           </a:p>
           <a:p>
             <a:pPr lvl="2"/>
             <a:r>
-              <a:rPr lang="en-US" smtClean="0"/>
+              <a:rPr lang="en-US"/>
               <a:t>Third level</a:t>
             </a:r>
           </a:p>
           <a:p>
             <a:pPr lvl="3"/>
             <a:r>
-              <a:rPr lang="en-US" smtClean="0"/>
+              <a:rPr lang="en-US"/>
               <a:t>Fourth level</a:t>
             </a:r>
           </a:p>
           <a:p>
             <a:pPr lvl="4"/>
             <a:r>
-              <a:rPr lang="en-US" smtClean="0"/>
+              <a:rPr lang="en-US"/>
               <a:t>Fifth level</a:t>
             </a:r>
-            <a:endParaRPr lang="en-US"/>
           </a:p>
         </p:txBody>
       </p:sp>
@@ -2574,7 +2587,7 @@
           <a:p>
             <a:fld id="{5BCAD085-E8A6-8845-BD4E-CB4CCA059FC4}" type="datetimeFigureOut">
               <a:rPr lang="en-US" smtClean="0"/>
-              <a:t>1/27/13</a:t>
+              <a:t>7/9/26</a:t>
             </a:fld>
             <a:endParaRPr lang="en-US"/>
           </a:p>
@@ -2668,10 +2681,9 @@
           <a:lstStyle/>
           <a:p>
             <a:r>
-              <a:rPr lang="en-US" smtClean="0"/>
+              <a:rPr lang="en-US"/>
               <a:t>Click to edit Master title style</a:t>
             </a:r>
-            <a:endParaRPr lang="en-US"/>
           </a:p>
         </p:txBody>
       </p:sp>
@@ -2692,38 +2704,37 @@
           <a:p>
             <a:pPr lvl="0"/>
             <a:r>
-              <a:rPr lang="en-US" smtClean="0"/>
+              <a:rPr lang="en-US"/>
               <a:t>Click to edit Master text styles</a:t>
             </a:r>
           </a:p>
           <a:p>
             <a:pPr lvl="1"/>
             <a:r>
-              <a:rPr lang="en-US" smtClean="0"/>
+              <a:rPr lang="en-US"/>
               <a:t>Second level</a:t>
             </a:r>
           </a:p>
           <a:p>
             <a:pPr lvl="2"/>
             <a:r>
-              <a:rPr lang="en-US" smtClean="0"/>
+              <a:rPr lang="en-US"/>
               <a:t>Third level</a:t>
             </a:r>
           </a:p>
           <a:p>
             <a:pPr lvl="3"/>
             <a:r>
-              <a:rPr lang="en-US" smtClean="0"/>
+              <a:rPr lang="en-US"/>
               <a:t>Fourth level</a:t>
             </a:r>
           </a:p>
           <a:p>
             <a:pPr lvl="4"/>
             <a:r>
-              <a:rPr lang="en-US" smtClean="0"/>
+              <a:rPr lang="en-US"/>
               <a:t>Fifth level</a:t>
             </a:r>
-            <a:endParaRPr lang="en-US"/>
           </a:p>
         </p:txBody>
       </p:sp>
@@ -2744,7 +2755,7 @@
           <a:p>
             <a:fld id="{5BCAD085-E8A6-8845-BD4E-CB4CCA059FC4}" type="datetimeFigureOut">
               <a:rPr lang="en-US" smtClean="0"/>
-              <a:t>1/27/13</a:t>
+              <a:t>7/9/26</a:t>
             </a:fld>
             <a:endParaRPr lang="en-US"/>
           </a:p>
@@ -2847,10 +2858,9 @@
           </a:lstStyle>
           <a:p>
             <a:r>
-              <a:rPr lang="en-US" smtClean="0"/>
+              <a:rPr lang="en-US"/>
               <a:t>Click to edit Master title style</a:t>
             </a:r>
-            <a:endParaRPr lang="en-US"/>
           </a:p>
         </p:txBody>
       </p:sp>
@@ -2967,7 +2977,7 @@
           <a:p>
             <a:pPr lvl="0"/>
             <a:r>
-              <a:rPr lang="en-US" smtClean="0"/>
+              <a:rPr lang="en-US"/>
               <a:t>Click to edit Master text styles</a:t>
             </a:r>
           </a:p>
@@ -2990,7 +3000,7 @@
           <a:p>
             <a:fld id="{5BCAD085-E8A6-8845-BD4E-CB4CCA059FC4}" type="datetimeFigureOut">
               <a:rPr lang="en-US" smtClean="0"/>
-              <a:t>1/27/13</a:t>
+              <a:t>7/9/26</a:t>
             </a:fld>
             <a:endParaRPr lang="en-US"/>
           </a:p>
@@ -3084,10 +3094,9 @@
           <a:lstStyle/>
           <a:p>
             <a:r>
-              <a:rPr lang="en-US" smtClean="0"/>
+              <a:rPr lang="en-US"/>
               <a:t>Click to edit Master title style</a:t>
             </a:r>
-            <a:endParaRPr lang="en-US"/>
           </a:p>
         </p:txBody>
       </p:sp>
@@ -3141,38 +3150,37 @@
           <a:p>
             <a:pPr lvl="0"/>
             <a:r>
-              <a:rPr lang="en-US" smtClean="0"/>
+              <a:rPr lang="en-US"/>
               <a:t>Click to edit Master text styles</a:t>
             </a:r>
           </a:p>
           <a:p>
             <a:pPr lvl="1"/>
             <a:r>
-              <a:rPr lang="en-US" smtClean="0"/>
+              <a:rPr lang="en-US"/>
               <a:t>Second level</a:t>
             </a:r>
           </a:p>
           <a:p>
             <a:pPr lvl="2"/>
             <a:r>
-              <a:rPr lang="en-US" smtClean="0"/>
+              <a:rPr lang="en-US"/>
               <a:t>Third level</a:t>
             </a:r>
           </a:p>
           <a:p>
             <a:pPr lvl="3"/>
             <a:r>
-              <a:rPr lang="en-US" smtClean="0"/>
+              <a:rPr lang="en-US"/>
               <a:t>Fourth level</a:t>
             </a:r>
           </a:p>
           <a:p>
             <a:pPr lvl="4"/>
             <a:r>
-              <a:rPr lang="en-US" smtClean="0"/>
+              <a:rPr lang="en-US"/>
               <a:t>Fifth level</a:t>
             </a:r>
-            <a:endParaRPr lang="en-US"/>
           </a:p>
         </p:txBody>
       </p:sp>
@@ -3226,38 +3234,37 @@
           <a:p>
             <a:pPr lvl="0"/>
             <a:r>
-              <a:rPr lang="en-US" smtClean="0"/>
+              <a:rPr lang="en-US"/>
               <a:t>Click to edit Master text styles</a:t>
             </a:r>
           </a:p>
           <a:p>
             <a:pPr lvl="1"/>
             <a:r>
-              <a:rPr lang="en-US" smtClean="0"/>
+              <a:rPr lang="en-US"/>
               <a:t>Second level</a:t>
             </a:r>
           </a:p>
           <a:p>
             <a:pPr lvl="2"/>
             <a:r>
-              <a:rPr lang="en-US" smtClean="0"/>
+              <a:rPr lang="en-US"/>
               <a:t>Third level</a:t>
             </a:r>
           </a:p>
           <a:p>
             <a:pPr lvl="3"/>
             <a:r>
-              <a:rPr lang="en-US" smtClean="0"/>
+              <a:rPr lang="en-US"/>
               <a:t>Fourth level</a:t>
             </a:r>
           </a:p>
           <a:p>
             <a:pPr lvl="4"/>
             <a:r>
-              <a:rPr lang="en-US" smtClean="0"/>
+              <a:rPr lang="en-US"/>
               <a:t>Fifth level</a:t>
             </a:r>
-            <a:endParaRPr lang="en-US"/>
           </a:p>
         </p:txBody>
       </p:sp>
@@ -3278,7 +3285,7 @@
           <a:p>
             <a:fld id="{5BCAD085-E8A6-8845-BD4E-CB4CCA059FC4}" type="datetimeFigureOut">
               <a:rPr lang="en-US" smtClean="0"/>
-              <a:t>1/27/13</a:t>
+              <a:t>7/9/26</a:t>
             </a:fld>
             <a:endParaRPr lang="en-US"/>
           </a:p>
@@ -3376,10 +3383,9 @@
           </a:lstStyle>
           <a:p>
             <a:r>
-              <a:rPr lang="en-US" smtClean="0"/>
+              <a:rPr lang="en-US"/>
               <a:t>Click to edit Master title style</a:t>
             </a:r>
-            <a:endParaRPr lang="en-US"/>
           </a:p>
         </p:txBody>
       </p:sp>
@@ -3442,7 +3448,7 @@
           <a:p>
             <a:pPr lvl="0"/>
             <a:r>
-              <a:rPr lang="en-US" smtClean="0"/>
+              <a:rPr lang="en-US"/>
               <a:t>Click to edit Master text styles</a:t>
             </a:r>
           </a:p>
@@ -3498,38 +3504,37 @@
           <a:p>
             <a:pPr lvl="0"/>
             <a:r>
-              <a:rPr lang="en-US" smtClean="0"/>
+              <a:rPr lang="en-US"/>
               <a:t>Click to edit Master text styles</a:t>
             </a:r>
           </a:p>
           <a:p>
             <a:pPr lvl="1"/>
             <a:r>
-              <a:rPr lang="en-US" smtClean="0"/>
+              <a:rPr lang="en-US"/>
               <a:t>Second level</a:t>
             </a:r>
           </a:p>
           <a:p>
             <a:pPr lvl="2"/>
             <a:r>
-              <a:rPr lang="en-US" smtClean="0"/>
+              <a:rPr lang="en-US"/>
               <a:t>Third level</a:t>
             </a:r>
           </a:p>
           <a:p>
             <a:pPr lvl="3"/>
             <a:r>
-              <a:rPr lang="en-US" smtClean="0"/>
+              <a:rPr lang="en-US"/>
               <a:t>Fourth level</a:t>
             </a:r>
           </a:p>
           <a:p>
             <a:pPr lvl="4"/>
             <a:r>
-              <a:rPr lang="en-US" smtClean="0"/>
+              <a:rPr lang="en-US"/>
               <a:t>Fifth level</a:t>
             </a:r>
-            <a:endParaRPr lang="en-US"/>
           </a:p>
         </p:txBody>
       </p:sp>
@@ -3592,7 +3597,7 @@
           <a:p>
             <a:pPr lvl="0"/>
             <a:r>
-              <a:rPr lang="en-US" smtClean="0"/>
+              <a:rPr lang="en-US"/>
               <a:t>Click to edit Master text styles</a:t>
             </a:r>
           </a:p>
@@ -3648,38 +3653,37 @@
           <a:p>
             <a:pPr lvl="0"/>
             <a:r>
-              <a:rPr lang="en-US" smtClean="0"/>
+              <a:rPr lang="en-US"/>
               <a:t>Click to edit Master text styles</a:t>
             </a:r>
           </a:p>
           <a:p>
             <a:pPr lvl="1"/>
             <a:r>
-              <a:rPr lang="en-US" smtClean="0"/>
+              <a:rPr lang="en-US"/>
               <a:t>Second level</a:t>
             </a:r>
           </a:p>
           <a:p>
             <a:pPr lvl="2"/>
             <a:r>
-              <a:rPr lang="en-US" smtClean="0"/>
+              <a:rPr lang="en-US"/>
               <a:t>Third level</a:t>
             </a:r>
           </a:p>
           <a:p>
             <a:pPr lvl="3"/>
             <a:r>
-              <a:rPr lang="en-US" smtClean="0"/>
+              <a:rPr lang="en-US"/>
               <a:t>Fourth level</a:t>
             </a:r>
           </a:p>
           <a:p>
             <a:pPr lvl="4"/>
             <a:r>
-              <a:rPr lang="en-US" smtClean="0"/>
+              <a:rPr lang="en-US"/>
               <a:t>Fifth level</a:t>
             </a:r>
-            <a:endParaRPr lang="en-US"/>
           </a:p>
         </p:txBody>
       </p:sp>
@@ -3700,7 +3704,7 @@
           <a:p>
             <a:fld id="{5BCAD085-E8A6-8845-BD4E-CB4CCA059FC4}" type="datetimeFigureOut">
               <a:rPr lang="en-US" smtClean="0"/>
-              <a:t>1/27/13</a:t>
+              <a:t>7/9/26</a:t>
             </a:fld>
             <a:endParaRPr lang="en-US"/>
           </a:p>
@@ -3794,10 +3798,9 @@
           <a:lstStyle/>
           <a:p>
             <a:r>
-              <a:rPr lang="en-US" smtClean="0"/>
+              <a:rPr lang="en-US"/>
               <a:t>Click to edit Master title style</a:t>
             </a:r>
-            <a:endParaRPr lang="en-US"/>
           </a:p>
         </p:txBody>
       </p:sp>
@@ -3818,7 +3821,7 @@
           <a:p>
             <a:fld id="{5BCAD085-E8A6-8845-BD4E-CB4CCA059FC4}" type="datetimeFigureOut">
               <a:rPr lang="en-US" smtClean="0"/>
-              <a:t>1/27/13</a:t>
+              <a:t>7/9/26</a:t>
             </a:fld>
             <a:endParaRPr lang="en-US"/>
           </a:p>
@@ -3913,7 +3916,7 @@
           <a:p>
             <a:fld id="{5BCAD085-E8A6-8845-BD4E-CB4CCA059FC4}" type="datetimeFigureOut">
               <a:rPr lang="en-US" smtClean="0"/>
-              <a:t>1/27/13</a:t>
+              <a:t>7/9/26</a:t>
             </a:fld>
             <a:endParaRPr lang="en-US"/>
           </a:p>
@@ -4016,10 +4019,9 @@
           </a:lstStyle>
           <a:p>
             <a:r>
-              <a:rPr lang="en-US" smtClean="0"/>
+              <a:rPr lang="en-US"/>
               <a:t>Click to edit Master title style</a:t>
             </a:r>
-            <a:endParaRPr lang="en-US"/>
           </a:p>
         </p:txBody>
       </p:sp>
@@ -4073,38 +4075,37 @@
           <a:p>
             <a:pPr lvl="0"/>
             <a:r>
-              <a:rPr lang="en-US" smtClean="0"/>
+              <a:rPr lang="en-US"/>
               <a:t>Click to edit Master text styles</a:t>
             </a:r>
           </a:p>
           <a:p>
             <a:pPr lvl="1"/>
             <a:r>
-              <a:rPr lang="en-US" smtClean="0"/>
+              <a:rPr lang="en-US"/>
               <a:t>Second level</a:t>
             </a:r>
           </a:p>
           <a:p>
             <a:pPr lvl="2"/>
             <a:r>
-              <a:rPr lang="en-US" smtClean="0"/>
+              <a:rPr lang="en-US"/>
               <a:t>Third level</a:t>
             </a:r>
           </a:p>
           <a:p>
             <a:pPr lvl="3"/>
             <a:r>
-              <a:rPr lang="en-US" smtClean="0"/>
+              <a:rPr lang="en-US"/>
               <a:t>Fourth level</a:t>
             </a:r>
           </a:p>
           <a:p>
             <a:pPr lvl="4"/>
             <a:r>
-              <a:rPr lang="en-US" smtClean="0"/>
+              <a:rPr lang="en-US"/>
               <a:t>Fifth level</a:t>
             </a:r>
-            <a:endParaRPr lang="en-US"/>
           </a:p>
         </p:txBody>
       </p:sp>
@@ -4167,7 +4168,7 @@
           <a:p>
             <a:pPr lvl="0"/>
             <a:r>
-              <a:rPr lang="en-US" smtClean="0"/>
+              <a:rPr lang="en-US"/>
               <a:t>Click to edit Master text styles</a:t>
             </a:r>
           </a:p>
@@ -4190,7 +4191,7 @@
           <a:p>
             <a:fld id="{5BCAD085-E8A6-8845-BD4E-CB4CCA059FC4}" type="datetimeFigureOut">
               <a:rPr lang="en-US" smtClean="0"/>
-              <a:t>1/27/13</a:t>
+              <a:t>7/9/26</a:t>
             </a:fld>
             <a:endParaRPr lang="en-US"/>
           </a:p>
@@ -4293,10 +4294,9 @@
           </a:lstStyle>
           <a:p>
             <a:r>
-              <a:rPr lang="en-US" smtClean="0"/>
+              <a:rPr lang="en-US"/>
               <a:t>Click to edit Master title style</a:t>
             </a:r>
-            <a:endParaRPr lang="en-US"/>
           </a:p>
         </p:txBody>
       </p:sp>
@@ -4420,7 +4420,7 @@
           <a:p>
             <a:pPr lvl="0"/>
             <a:r>
-              <a:rPr lang="en-US" smtClean="0"/>
+              <a:rPr lang="en-US"/>
               <a:t>Click to edit Master text styles</a:t>
             </a:r>
           </a:p>
@@ -4443,7 +4443,7 @@
           <a:p>
             <a:fld id="{5BCAD085-E8A6-8845-BD4E-CB4CCA059FC4}" type="datetimeFigureOut">
               <a:rPr lang="en-US" smtClean="0"/>
-              <a:t>1/27/13</a:t>
+              <a:t>7/9/26</a:t>
             </a:fld>
             <a:endParaRPr lang="en-US"/>
           </a:p>
@@ -4552,10 +4552,9 @@
           <a:lstStyle/>
           <a:p>
             <a:r>
-              <a:rPr lang="en-US" smtClean="0"/>
+              <a:rPr lang="en-US"/>
               <a:t>Click to edit Master title style</a:t>
             </a:r>
-            <a:endParaRPr lang="en-US"/>
           </a:p>
         </p:txBody>
       </p:sp>
@@ -4586,38 +4585,37 @@
           <a:p>
             <a:pPr lvl="0"/>
             <a:r>
-              <a:rPr lang="en-US" smtClean="0"/>
+              <a:rPr lang="en-US"/>
               <a:t>Click to edit Master text styles</a:t>
             </a:r>
           </a:p>
           <a:p>
             <a:pPr lvl="1"/>
             <a:r>
-              <a:rPr lang="en-US" smtClean="0"/>
+              <a:rPr lang="en-US"/>
               <a:t>Second level</a:t>
             </a:r>
           </a:p>
           <a:p>
             <a:pPr lvl="2"/>
             <a:r>
-              <a:rPr lang="en-US" smtClean="0"/>
+              <a:rPr lang="en-US"/>
               <a:t>Third level</a:t>
             </a:r>
           </a:p>
           <a:p>
             <a:pPr lvl="3"/>
             <a:r>
-              <a:rPr lang="en-US" smtClean="0"/>
+              <a:rPr lang="en-US"/>
               <a:t>Fourth level</a:t>
             </a:r>
           </a:p>
           <a:p>
             <a:pPr lvl="4"/>
             <a:r>
-              <a:rPr lang="en-US" smtClean="0"/>
+              <a:rPr lang="en-US"/>
               <a:t>Fifth level</a:t>
             </a:r>
-            <a:endParaRPr lang="en-US"/>
           </a:p>
         </p:txBody>
       </p:sp>
@@ -4656,7 +4654,7 @@
           <a:p>
             <a:fld id="{5BCAD085-E8A6-8845-BD4E-CB4CCA059FC4}" type="datetimeFigureOut">
               <a:rPr lang="en-US" smtClean="0"/>
-              <a:t>1/27/13</a:t>
+              <a:t>7/9/26</a:t>
             </a:fld>
             <a:endParaRPr lang="en-US"/>
           </a:p>
@@ -5015,7 +5013,7 @@
 </file>
 
 <file path=ppt/slides/slide1.xml><?xml version="1.0" encoding="utf-8"?>
-<p:sld xmlns:a="http://schemas.openxmlformats.org/drawingml/2006/main" xmlns:p="http://schemas.openxmlformats.org/presentationml/2006/main" xmlns:r="http://schemas.openxmlformats.org/officeDocument/2006/relationships">
+<p:sld xmlns:a="http://schemas.openxmlformats.org/drawingml/2006/main" xmlns:r="http://schemas.openxmlformats.org/officeDocument/2006/relationships" xmlns:p="http://schemas.openxmlformats.org/presentationml/2006/main">
   <p:cSld>
     <p:bg>
       <p:bgPr>
@@ -5031,7 +5029,14 @@
         <p:cNvGrpSpPr/>
         <p:nvPr/>
       </p:nvGrpSpPr>
-      <p:grpSpPr/>
+      <p:grpSpPr>
+        <a:xfrm>
+          <a:off x="0" y="0"/>
+          <a:ext cx="0" cy="0"/>
+          <a:chOff x="0" y="0"/>
+          <a:chExt cx="0" cy="0"/>
+        </a:xfrm>
+      </p:grpSpPr>
       <p:sp>
         <p:nvSpPr>
           <p:cNvPr id="2" name="Rectangle 1"/>
@@ -5073,6 +5078,7 @@
           <a:lstStyle/>
           <a:p>
             <a:pPr algn="ctr"/>
+            <a:endParaRPr/>
           </a:p>
         </p:txBody>
       </p:sp>
@@ -5093,7 +5099,7 @@
           <a:noFill/>
         </p:spPr>
         <p:txBody>
-          <a:bodyPr wrap="square" anchor="t" lIns="0" rIns="0" tIns="0" bIns="0">
+          <a:bodyPr wrap="square" lIns="0" tIns="0" rIns="0" bIns="0" anchor="t">
             <a:spAutoFit/>
           </a:bodyPr>
           <a:lstStyle/>
@@ -5159,7 +5165,7 @@
           <a:noFill/>
         </p:spPr>
         <p:txBody>
-          <a:bodyPr wrap="square" anchor="t" lIns="0" rIns="0" tIns="0" bIns="0">
+          <a:bodyPr wrap="square" lIns="0" tIns="0" rIns="0" bIns="0" anchor="t">
             <a:spAutoFit/>
           </a:bodyPr>
           <a:lstStyle/>
@@ -5194,7 +5200,7 @@
 </file>
 
 <file path=ppt/slides/slide10.xml><?xml version="1.0" encoding="utf-8"?>
-<p:sld xmlns:a="http://schemas.openxmlformats.org/drawingml/2006/main" xmlns:p="http://schemas.openxmlformats.org/presentationml/2006/main" xmlns:r="http://schemas.openxmlformats.org/officeDocument/2006/relationships">
+<p:sld xmlns:a="http://schemas.openxmlformats.org/drawingml/2006/main" xmlns:r="http://schemas.openxmlformats.org/officeDocument/2006/relationships" xmlns:p="http://schemas.openxmlformats.org/presentationml/2006/main">
   <p:cSld>
     <p:bg>
       <p:bgPr>
@@ -5210,7 +5216,14 @@
         <p:cNvGrpSpPr/>
         <p:nvPr/>
       </p:nvGrpSpPr>
-      <p:grpSpPr/>
+      <p:grpSpPr>
+        <a:xfrm>
+          <a:off x="0" y="0"/>
+          <a:ext cx="0" cy="0"/>
+          <a:chOff x="0" y="0"/>
+          <a:chExt cx="0" cy="0"/>
+        </a:xfrm>
+      </p:grpSpPr>
       <p:sp>
         <p:nvSpPr>
           <p:cNvPr id="2" name="TextBox 1"/>
@@ -5228,7 +5241,7 @@
           <a:noFill/>
         </p:spPr>
         <p:txBody>
-          <a:bodyPr wrap="square" anchor="t" lIns="0" rIns="0" tIns="0" bIns="0">
+          <a:bodyPr wrap="square" lIns="0" tIns="0" rIns="0" bIns="0" anchor="t">
             <a:spAutoFit/>
           </a:bodyPr>
           <a:lstStyle/>
@@ -5286,6 +5299,7 @@
           <a:lstStyle/>
           <a:p>
             <a:pPr algn="ctr"/>
+            <a:endParaRPr/>
           </a:p>
         </p:txBody>
       </p:sp>
@@ -5306,7 +5320,7 @@
           <a:noFill/>
         </p:spPr>
         <p:txBody>
-          <a:bodyPr wrap="square" anchor="ctr" lIns="0" rIns="0" tIns="0" bIns="0">
+          <a:bodyPr wrap="square" lIns="0" tIns="0" rIns="0" bIns="0" anchor="ctr">
             <a:spAutoFit/>
           </a:bodyPr>
           <a:lstStyle/>
@@ -5446,6 +5460,7 @@
           <a:lstStyle/>
           <a:p>
             <a:pPr algn="ctr"/>
+            <a:endParaRPr/>
           </a:p>
         </p:txBody>
       </p:sp>
@@ -5466,7 +5481,7 @@
           <a:noFill/>
         </p:spPr>
         <p:txBody>
-          <a:bodyPr wrap="square" anchor="t" lIns="0" rIns="0" tIns="0" bIns="0">
+          <a:bodyPr wrap="square" lIns="0" tIns="0" rIns="0" bIns="0" anchor="t">
             <a:spAutoFit/>
           </a:bodyPr>
           <a:lstStyle/>
@@ -5509,7 +5524,7 @@
           <a:noFill/>
         </p:spPr>
         <p:txBody>
-          <a:bodyPr wrap="square" anchor="t" lIns="0" rIns="0" tIns="0" bIns="0">
+          <a:bodyPr wrap="square" lIns="0" tIns="0" rIns="0" bIns="0" anchor="t">
             <a:spAutoFit/>
           </a:bodyPr>
           <a:lstStyle/>
@@ -5536,7 +5551,7 @@
 </file>
 
 <file path=ppt/slides/slide11.xml><?xml version="1.0" encoding="utf-8"?>
-<p:sld xmlns:a="http://schemas.openxmlformats.org/drawingml/2006/main" xmlns:p="http://schemas.openxmlformats.org/presentationml/2006/main" xmlns:r="http://schemas.openxmlformats.org/officeDocument/2006/relationships">
+<p:sld xmlns:a="http://schemas.openxmlformats.org/drawingml/2006/main" xmlns:r="http://schemas.openxmlformats.org/officeDocument/2006/relationships" xmlns:p="http://schemas.openxmlformats.org/presentationml/2006/main">
   <p:cSld>
     <p:bg>
       <p:bgPr>
@@ -5552,7 +5567,14 @@
         <p:cNvGrpSpPr/>
         <p:nvPr/>
       </p:nvGrpSpPr>
-      <p:grpSpPr/>
+      <p:grpSpPr>
+        <a:xfrm>
+          <a:off x="0" y="0"/>
+          <a:ext cx="0" cy="0"/>
+          <a:chOff x="0" y="0"/>
+          <a:chExt cx="0" cy="0"/>
+        </a:xfrm>
+      </p:grpSpPr>
       <p:sp>
         <p:nvSpPr>
           <p:cNvPr id="2" name="Rectangle 1"/>
@@ -5594,6 +5616,7 @@
           <a:lstStyle/>
           <a:p>
             <a:pPr algn="ctr"/>
+            <a:endParaRPr/>
           </a:p>
         </p:txBody>
       </p:sp>
@@ -5667,7 +5690,7 @@
           <a:noFill/>
         </p:spPr>
         <p:txBody>
-          <a:bodyPr wrap="square" anchor="ctr" lIns="0" rIns="0" tIns="0" bIns="0">
+          <a:bodyPr wrap="square" lIns="0" tIns="0" rIns="0" bIns="0" anchor="ctr">
             <a:spAutoFit/>
           </a:bodyPr>
           <a:lstStyle/>
@@ -5701,7 +5724,7 @@
           <a:noFill/>
         </p:spPr>
         <p:txBody>
-          <a:bodyPr wrap="square" anchor="t" lIns="0" rIns="0" tIns="0" bIns="0">
+          <a:bodyPr wrap="square" lIns="0" tIns="0" rIns="0" bIns="0" anchor="t">
             <a:spAutoFit/>
           </a:bodyPr>
           <a:lstStyle/>
@@ -5812,6 +5835,7 @@
           <a:lstStyle/>
           <a:p>
             <a:pPr algn="ctr"/>
+            <a:endParaRPr/>
           </a:p>
         </p:txBody>
       </p:sp>
@@ -5832,7 +5856,7 @@
           <a:noFill/>
         </p:spPr>
         <p:txBody>
-          <a:bodyPr wrap="square" anchor="ctr" lIns="0" rIns="0" tIns="0" bIns="0">
+          <a:bodyPr wrap="square" lIns="0" tIns="0" rIns="0" bIns="0" anchor="ctr">
             <a:spAutoFit/>
           </a:bodyPr>
           <a:lstStyle/>
@@ -5890,6 +5914,7 @@
           <a:lstStyle/>
           <a:p>
             <a:pPr algn="ctr"/>
+            <a:endParaRPr/>
           </a:p>
         </p:txBody>
       </p:sp>
@@ -5910,7 +5935,7 @@
           <a:noFill/>
         </p:spPr>
         <p:txBody>
-          <a:bodyPr wrap="square" anchor="t" lIns="0" rIns="0" tIns="0" bIns="0">
+          <a:bodyPr wrap="square" lIns="0" tIns="0" rIns="0" bIns="0" anchor="t">
             <a:spAutoFit/>
           </a:bodyPr>
           <a:lstStyle/>
@@ -5953,7 +5978,7 @@
           <a:noFill/>
         </p:spPr>
         <p:txBody>
-          <a:bodyPr wrap="square" anchor="t" lIns="0" rIns="0" tIns="0" bIns="0">
+          <a:bodyPr wrap="square" lIns="0" tIns="0" rIns="0" bIns="0" anchor="t">
             <a:spAutoFit/>
           </a:bodyPr>
           <a:lstStyle/>
@@ -5980,7 +6005,7 @@
 </file>
 
 <file path=ppt/slides/slide12.xml><?xml version="1.0" encoding="utf-8"?>
-<p:sld xmlns:a="http://schemas.openxmlformats.org/drawingml/2006/main" xmlns:p="http://schemas.openxmlformats.org/presentationml/2006/main" xmlns:r="http://schemas.openxmlformats.org/officeDocument/2006/relationships">
+<p:sld xmlns:a="http://schemas.openxmlformats.org/drawingml/2006/main" xmlns:r="http://schemas.openxmlformats.org/officeDocument/2006/relationships" xmlns:p="http://schemas.openxmlformats.org/presentationml/2006/main">
   <p:cSld>
     <p:bg>
       <p:bgPr>
@@ -5996,7 +6021,14 @@
         <p:cNvGrpSpPr/>
         <p:nvPr/>
       </p:nvGrpSpPr>
-      <p:grpSpPr/>
+      <p:grpSpPr>
+        <a:xfrm>
+          <a:off x="0" y="0"/>
+          <a:ext cx="0" cy="0"/>
+          <a:chOff x="0" y="0"/>
+          <a:chExt cx="0" cy="0"/>
+        </a:xfrm>
+      </p:grpSpPr>
       <p:sp>
         <p:nvSpPr>
           <p:cNvPr id="2" name="Rectangle 1"/>
@@ -6038,6 +6070,7 @@
           <a:lstStyle/>
           <a:p>
             <a:pPr algn="ctr"/>
+            <a:endParaRPr/>
           </a:p>
         </p:txBody>
       </p:sp>
@@ -6058,7 +6091,7 @@
           <a:noFill/>
         </p:spPr>
         <p:txBody>
-          <a:bodyPr wrap="square" anchor="t" lIns="0" rIns="0" tIns="0" bIns="0">
+          <a:bodyPr wrap="square" lIns="0" tIns="0" rIns="0" bIns="0" anchor="t">
             <a:spAutoFit/>
           </a:bodyPr>
           <a:lstStyle/>
@@ -6092,7 +6125,7 @@
           <a:noFill/>
         </p:spPr>
         <p:txBody>
-          <a:bodyPr wrap="square" anchor="t" lIns="0" rIns="0" tIns="0" bIns="0">
+          <a:bodyPr wrap="square" lIns="0" tIns="0" rIns="0" bIns="0" anchor="t">
             <a:spAutoFit/>
           </a:bodyPr>
           <a:lstStyle/>
@@ -6182,6 +6215,7 @@
           <a:lstStyle/>
           <a:p>
             <a:pPr algn="ctr"/>
+            <a:endParaRPr/>
           </a:p>
         </p:txBody>
       </p:sp>
@@ -6202,7 +6236,7 @@
           <a:noFill/>
         </p:spPr>
         <p:txBody>
-          <a:bodyPr wrap="square" anchor="t" lIns="0" rIns="0" tIns="0" bIns="0">
+          <a:bodyPr wrap="square" lIns="0" tIns="0" rIns="0" bIns="0" anchor="t">
             <a:spAutoFit/>
           </a:bodyPr>
           <a:lstStyle/>
@@ -6245,21 +6279,13 @@
           <a:noFill/>
         </p:spPr>
         <p:txBody>
-          <a:bodyPr wrap="square" anchor="t" lIns="0" rIns="0" tIns="0" bIns="0">
+          <a:bodyPr wrap="square" lIns="0" tIns="0" rIns="0" bIns="0" anchor="t">
             <a:spAutoFit/>
           </a:bodyPr>
           <a:lstStyle/>
           <a:p>
             <a:pPr algn="r"/>
-            <a:r>
-              <a:rPr sz="1100" b="0" i="0">
-                <a:solidFill>
-                  <a:srgbClr val="7A7A7A"/>
-                </a:solidFill>
-                <a:latin typeface="Roboto"/>
-              </a:rPr>
-              <a:t/>
-            </a:r>
+            <a:endParaRPr/>
           </a:p>
         </p:txBody>
       </p:sp>
@@ -6272,7 +6298,7 @@
 </file>
 
 <file path=ppt/slides/slide13.xml><?xml version="1.0" encoding="utf-8"?>
-<p:sld xmlns:a="http://schemas.openxmlformats.org/drawingml/2006/main" xmlns:p="http://schemas.openxmlformats.org/presentationml/2006/main" xmlns:r="http://schemas.openxmlformats.org/officeDocument/2006/relationships">
+<p:sld xmlns:a="http://schemas.openxmlformats.org/drawingml/2006/main" xmlns:r="http://schemas.openxmlformats.org/officeDocument/2006/relationships" xmlns:p="http://schemas.openxmlformats.org/presentationml/2006/main">
   <p:cSld>
     <p:bg>
       <p:bgPr>
@@ -6288,7 +6314,14 @@
         <p:cNvGrpSpPr/>
         <p:nvPr/>
       </p:nvGrpSpPr>
-      <p:grpSpPr/>
+      <p:grpSpPr>
+        <a:xfrm>
+          <a:off x="0" y="0"/>
+          <a:ext cx="0" cy="0"/>
+          <a:chOff x="0" y="0"/>
+          <a:chExt cx="0" cy="0"/>
+        </a:xfrm>
+      </p:grpSpPr>
       <p:sp>
         <p:nvSpPr>
           <p:cNvPr id="2" name="TextBox 1"/>
@@ -6306,7 +6339,7 @@
           <a:noFill/>
         </p:spPr>
         <p:txBody>
-          <a:bodyPr wrap="square" anchor="t" lIns="0" rIns="0" tIns="0" bIns="0">
+          <a:bodyPr wrap="square" lIns="0" tIns="0" rIns="0" bIns="0" anchor="t">
             <a:spAutoFit/>
           </a:bodyPr>
           <a:lstStyle/>
@@ -6364,6 +6397,7 @@
           <a:lstStyle/>
           <a:p>
             <a:pPr algn="ctr"/>
+            <a:endParaRPr/>
           </a:p>
         </p:txBody>
       </p:sp>
@@ -6384,7 +6418,7 @@
           <a:noFill/>
         </p:spPr>
         <p:txBody>
-          <a:bodyPr wrap="square" anchor="ctr" lIns="0" rIns="0" tIns="0" bIns="0">
+          <a:bodyPr wrap="square" lIns="0" tIns="0" rIns="0" bIns="0" anchor="ctr">
             <a:spAutoFit/>
           </a:bodyPr>
           <a:lstStyle/>
@@ -6524,6 +6558,7 @@
           <a:lstStyle/>
           <a:p>
             <a:pPr algn="ctr"/>
+            <a:endParaRPr/>
           </a:p>
         </p:txBody>
       </p:sp>
@@ -6544,7 +6579,7 @@
           <a:noFill/>
         </p:spPr>
         <p:txBody>
-          <a:bodyPr wrap="square" anchor="t" lIns="0" rIns="0" tIns="0" bIns="0">
+          <a:bodyPr wrap="square" lIns="0" tIns="0" rIns="0" bIns="0" anchor="t">
             <a:spAutoFit/>
           </a:bodyPr>
           <a:lstStyle/>
@@ -6587,7 +6622,7 @@
           <a:noFill/>
         </p:spPr>
         <p:txBody>
-          <a:bodyPr wrap="square" anchor="t" lIns="0" rIns="0" tIns="0" bIns="0">
+          <a:bodyPr wrap="square" lIns="0" tIns="0" rIns="0" bIns="0" anchor="t">
             <a:spAutoFit/>
           </a:bodyPr>
           <a:lstStyle/>
@@ -6614,7 +6649,7 @@
 </file>
 
 <file path=ppt/slides/slide14.xml><?xml version="1.0" encoding="utf-8"?>
-<p:sld xmlns:a="http://schemas.openxmlformats.org/drawingml/2006/main" xmlns:p="http://schemas.openxmlformats.org/presentationml/2006/main" xmlns:r="http://schemas.openxmlformats.org/officeDocument/2006/relationships">
+<p:sld xmlns:a="http://schemas.openxmlformats.org/drawingml/2006/main" xmlns:r="http://schemas.openxmlformats.org/officeDocument/2006/relationships" xmlns:p="http://schemas.openxmlformats.org/presentationml/2006/main">
   <p:cSld>
     <p:bg>
       <p:bgPr>
@@ -6630,7 +6665,14 @@
         <p:cNvGrpSpPr/>
         <p:nvPr/>
       </p:nvGrpSpPr>
-      <p:grpSpPr/>
+      <p:grpSpPr>
+        <a:xfrm>
+          <a:off x="0" y="0"/>
+          <a:ext cx="0" cy="0"/>
+          <a:chOff x="0" y="0"/>
+          <a:chExt cx="0" cy="0"/>
+        </a:xfrm>
+      </p:grpSpPr>
       <p:sp>
         <p:nvSpPr>
           <p:cNvPr id="2" name="TextBox 1"/>
@@ -6648,7 +6690,7 @@
           <a:noFill/>
         </p:spPr>
         <p:txBody>
-          <a:bodyPr wrap="square" anchor="t" lIns="0" rIns="0" tIns="0" bIns="0">
+          <a:bodyPr wrap="square" lIns="0" tIns="0" rIns="0" bIns="0" anchor="t">
             <a:spAutoFit/>
           </a:bodyPr>
           <a:lstStyle/>
@@ -6706,6 +6748,7 @@
           <a:lstStyle/>
           <a:p>
             <a:pPr algn="ctr"/>
+            <a:endParaRPr/>
           </a:p>
         </p:txBody>
       </p:sp>
@@ -6726,7 +6769,7 @@
           <a:noFill/>
         </p:spPr>
         <p:txBody>
-          <a:bodyPr wrap="square" anchor="ctr" lIns="0" rIns="0" tIns="0" bIns="0">
+          <a:bodyPr wrap="square" lIns="0" tIns="0" rIns="0" bIns="0" anchor="ctr">
             <a:spAutoFit/>
           </a:bodyPr>
           <a:lstStyle/>
@@ -6866,6 +6909,7 @@
           <a:lstStyle/>
           <a:p>
             <a:pPr algn="ctr"/>
+            <a:endParaRPr/>
           </a:p>
         </p:txBody>
       </p:sp>
@@ -6886,7 +6930,7 @@
           <a:noFill/>
         </p:spPr>
         <p:txBody>
-          <a:bodyPr wrap="square" anchor="t" lIns="0" rIns="0" tIns="0" bIns="0">
+          <a:bodyPr wrap="square" lIns="0" tIns="0" rIns="0" bIns="0" anchor="t">
             <a:spAutoFit/>
           </a:bodyPr>
           <a:lstStyle/>
@@ -6929,7 +6973,7 @@
           <a:noFill/>
         </p:spPr>
         <p:txBody>
-          <a:bodyPr wrap="square" anchor="t" lIns="0" rIns="0" tIns="0" bIns="0">
+          <a:bodyPr wrap="square" lIns="0" tIns="0" rIns="0" bIns="0" anchor="t">
             <a:spAutoFit/>
           </a:bodyPr>
           <a:lstStyle/>
@@ -6956,7 +7000,7 @@
 </file>
 
 <file path=ppt/slides/slide15.xml><?xml version="1.0" encoding="utf-8"?>
-<p:sld xmlns:a="http://schemas.openxmlformats.org/drawingml/2006/main" xmlns:p="http://schemas.openxmlformats.org/presentationml/2006/main" xmlns:r="http://schemas.openxmlformats.org/officeDocument/2006/relationships">
+<p:sld xmlns:a="http://schemas.openxmlformats.org/drawingml/2006/main" xmlns:r="http://schemas.openxmlformats.org/officeDocument/2006/relationships" xmlns:p="http://schemas.openxmlformats.org/presentationml/2006/main">
   <p:cSld>
     <p:bg>
       <p:bgPr>
@@ -6972,7 +7016,14 @@
         <p:cNvGrpSpPr/>
         <p:nvPr/>
       </p:nvGrpSpPr>
-      <p:grpSpPr/>
+      <p:grpSpPr>
+        <a:xfrm>
+          <a:off x="0" y="0"/>
+          <a:ext cx="0" cy="0"/>
+          <a:chOff x="0" y="0"/>
+          <a:chExt cx="0" cy="0"/>
+        </a:xfrm>
+      </p:grpSpPr>
       <p:sp>
         <p:nvSpPr>
           <p:cNvPr id="2" name="Rectangle 1"/>
@@ -7014,6 +7065,7 @@
           <a:lstStyle/>
           <a:p>
             <a:pPr algn="ctr"/>
+            <a:endParaRPr/>
           </a:p>
         </p:txBody>
       </p:sp>
@@ -7087,7 +7139,7 @@
           <a:noFill/>
         </p:spPr>
         <p:txBody>
-          <a:bodyPr wrap="square" anchor="ctr" lIns="0" rIns="0" tIns="0" bIns="0">
+          <a:bodyPr wrap="square" lIns="0" tIns="0" rIns="0" bIns="0" anchor="ctr">
             <a:spAutoFit/>
           </a:bodyPr>
           <a:lstStyle/>
@@ -7121,7 +7173,7 @@
           <a:noFill/>
         </p:spPr>
         <p:txBody>
-          <a:bodyPr wrap="square" anchor="t" lIns="0" rIns="0" tIns="0" bIns="0">
+          <a:bodyPr wrap="square" lIns="0" tIns="0" rIns="0" bIns="0" anchor="t">
             <a:spAutoFit/>
           </a:bodyPr>
           <a:lstStyle/>
@@ -7232,6 +7284,7 @@
           <a:lstStyle/>
           <a:p>
             <a:pPr algn="ctr"/>
+            <a:endParaRPr/>
           </a:p>
         </p:txBody>
       </p:sp>
@@ -7252,7 +7305,7 @@
           <a:noFill/>
         </p:spPr>
         <p:txBody>
-          <a:bodyPr wrap="square" anchor="ctr" lIns="0" rIns="0" tIns="0" bIns="0">
+          <a:bodyPr wrap="square" lIns="0" tIns="0" rIns="0" bIns="0" anchor="ctr">
             <a:spAutoFit/>
           </a:bodyPr>
           <a:lstStyle/>
@@ -7310,6 +7363,7 @@
           <a:lstStyle/>
           <a:p>
             <a:pPr algn="ctr"/>
+            <a:endParaRPr/>
           </a:p>
         </p:txBody>
       </p:sp>
@@ -7330,7 +7384,7 @@
           <a:noFill/>
         </p:spPr>
         <p:txBody>
-          <a:bodyPr wrap="square" anchor="t" lIns="0" rIns="0" tIns="0" bIns="0">
+          <a:bodyPr wrap="square" lIns="0" tIns="0" rIns="0" bIns="0" anchor="t">
             <a:spAutoFit/>
           </a:bodyPr>
           <a:lstStyle/>
@@ -7373,7 +7427,7 @@
           <a:noFill/>
         </p:spPr>
         <p:txBody>
-          <a:bodyPr wrap="square" anchor="t" lIns="0" rIns="0" tIns="0" bIns="0">
+          <a:bodyPr wrap="square" lIns="0" tIns="0" rIns="0" bIns="0" anchor="t">
             <a:spAutoFit/>
           </a:bodyPr>
           <a:lstStyle/>
@@ -7400,7 +7454,7 @@
 </file>
 
 <file path=ppt/slides/slide16.xml><?xml version="1.0" encoding="utf-8"?>
-<p:sld xmlns:a="http://schemas.openxmlformats.org/drawingml/2006/main" xmlns:p="http://schemas.openxmlformats.org/presentationml/2006/main" xmlns:r="http://schemas.openxmlformats.org/officeDocument/2006/relationships">
+<p:sld xmlns:a="http://schemas.openxmlformats.org/drawingml/2006/main" xmlns:r="http://schemas.openxmlformats.org/officeDocument/2006/relationships" xmlns:p="http://schemas.openxmlformats.org/presentationml/2006/main">
   <p:cSld>
     <p:bg>
       <p:bgPr>
@@ -7416,7 +7470,14 @@
         <p:cNvGrpSpPr/>
         <p:nvPr/>
       </p:nvGrpSpPr>
-      <p:grpSpPr/>
+      <p:grpSpPr>
+        <a:xfrm>
+          <a:off x="0" y="0"/>
+          <a:ext cx="0" cy="0"/>
+          <a:chOff x="0" y="0"/>
+          <a:chExt cx="0" cy="0"/>
+        </a:xfrm>
+      </p:grpSpPr>
       <p:sp>
         <p:nvSpPr>
           <p:cNvPr id="2" name="TextBox 1"/>
@@ -7434,7 +7495,7 @@
           <a:noFill/>
         </p:spPr>
         <p:txBody>
-          <a:bodyPr wrap="square" anchor="t" lIns="0" rIns="0" tIns="0" bIns="0">
+          <a:bodyPr wrap="square" lIns="0" tIns="0" rIns="0" bIns="0" anchor="t">
             <a:spAutoFit/>
           </a:bodyPr>
           <a:lstStyle/>
@@ -7508,6 +7569,7 @@
           <a:lstStyle/>
           <a:p>
             <a:pPr algn="ctr"/>
+            <a:endParaRPr/>
           </a:p>
         </p:txBody>
       </p:sp>
@@ -7554,6 +7616,7 @@
           <a:lstStyle/>
           <a:p>
             <a:pPr algn="ctr"/>
+            <a:endParaRPr/>
           </a:p>
         </p:txBody>
       </p:sp>
@@ -7598,6 +7661,7 @@
           <a:lstStyle/>
           <a:p>
             <a:pPr algn="ctr"/>
+            <a:endParaRPr/>
           </a:p>
         </p:txBody>
       </p:sp>
@@ -7618,7 +7682,7 @@
           <a:noFill/>
         </p:spPr>
         <p:txBody>
-          <a:bodyPr wrap="square" anchor="ctr" lIns="0" rIns="0" tIns="0" bIns="0">
+          <a:bodyPr wrap="square" lIns="0" tIns="0" rIns="0" bIns="0" anchor="ctr">
             <a:spAutoFit/>
           </a:bodyPr>
           <a:lstStyle/>
@@ -7683,6 +7747,7 @@
           <a:lstStyle/>
           <a:p>
             <a:pPr algn="ctr"/>
+            <a:endParaRPr/>
           </a:p>
         </p:txBody>
       </p:sp>
@@ -7727,6 +7792,7 @@
           <a:lstStyle/>
           <a:p>
             <a:pPr algn="ctr"/>
+            <a:endParaRPr/>
           </a:p>
         </p:txBody>
       </p:sp>
@@ -7747,7 +7813,7 @@
           <a:noFill/>
         </p:spPr>
         <p:txBody>
-          <a:bodyPr wrap="square" anchor="ctr" lIns="0" rIns="0" tIns="0" bIns="0">
+          <a:bodyPr wrap="square" lIns="0" tIns="0" rIns="0" bIns="0" anchor="ctr">
             <a:spAutoFit/>
           </a:bodyPr>
           <a:lstStyle/>
@@ -7812,6 +7878,7 @@
           <a:lstStyle/>
           <a:p>
             <a:pPr algn="ctr"/>
+            <a:endParaRPr/>
           </a:p>
         </p:txBody>
       </p:sp>
@@ -7856,6 +7923,7 @@
           <a:lstStyle/>
           <a:p>
             <a:pPr algn="ctr"/>
+            <a:endParaRPr/>
           </a:p>
         </p:txBody>
       </p:sp>
@@ -7876,7 +7944,7 @@
           <a:noFill/>
         </p:spPr>
         <p:txBody>
-          <a:bodyPr wrap="square" anchor="ctr" lIns="0" rIns="0" tIns="0" bIns="0">
+          <a:bodyPr wrap="square" lIns="0" tIns="0" rIns="0" bIns="0" anchor="ctr">
             <a:spAutoFit/>
           </a:bodyPr>
           <a:lstStyle/>
@@ -7941,6 +8009,7 @@
           <a:lstStyle/>
           <a:p>
             <a:pPr algn="ctr"/>
+            <a:endParaRPr/>
           </a:p>
         </p:txBody>
       </p:sp>
@@ -7985,6 +8054,7 @@
           <a:lstStyle/>
           <a:p>
             <a:pPr algn="ctr"/>
+            <a:endParaRPr/>
           </a:p>
         </p:txBody>
       </p:sp>
@@ -8005,7 +8075,7 @@
           <a:noFill/>
         </p:spPr>
         <p:txBody>
-          <a:bodyPr wrap="square" anchor="ctr" lIns="0" rIns="0" tIns="0" bIns="0">
+          <a:bodyPr wrap="square" lIns="0" tIns="0" rIns="0" bIns="0" anchor="ctr">
             <a:spAutoFit/>
           </a:bodyPr>
           <a:lstStyle/>
@@ -8068,6 +8138,7 @@
           <a:lstStyle/>
           <a:p>
             <a:pPr algn="ctr"/>
+            <a:endParaRPr/>
           </a:p>
         </p:txBody>
       </p:sp>
@@ -8088,7 +8159,7 @@
           <a:noFill/>
         </p:spPr>
         <p:txBody>
-          <a:bodyPr wrap="square" anchor="t" lIns="0" rIns="0" tIns="0" bIns="0">
+          <a:bodyPr wrap="square" lIns="0" tIns="0" rIns="0" bIns="0" anchor="t">
             <a:spAutoFit/>
           </a:bodyPr>
           <a:lstStyle/>
@@ -8131,7 +8202,7 @@
           <a:noFill/>
         </p:spPr>
         <p:txBody>
-          <a:bodyPr wrap="square" anchor="t" lIns="0" rIns="0" tIns="0" bIns="0">
+          <a:bodyPr wrap="square" lIns="0" tIns="0" rIns="0" bIns="0" anchor="t">
             <a:spAutoFit/>
           </a:bodyPr>
           <a:lstStyle/>
@@ -8158,7 +8229,7 @@
 </file>
 
 <file path=ppt/slides/slide17.xml><?xml version="1.0" encoding="utf-8"?>
-<p:sld xmlns:a="http://schemas.openxmlformats.org/drawingml/2006/main" xmlns:p="http://schemas.openxmlformats.org/presentationml/2006/main" xmlns:r="http://schemas.openxmlformats.org/officeDocument/2006/relationships">
+<p:sld xmlns:a="http://schemas.openxmlformats.org/drawingml/2006/main" xmlns:r="http://schemas.openxmlformats.org/officeDocument/2006/relationships" xmlns:p="http://schemas.openxmlformats.org/presentationml/2006/main">
   <p:cSld>
     <p:bg>
       <p:bgPr>
@@ -8174,7 +8245,14 @@
         <p:cNvGrpSpPr/>
         <p:nvPr/>
       </p:nvGrpSpPr>
-      <p:grpSpPr/>
+      <p:grpSpPr>
+        <a:xfrm>
+          <a:off x="0" y="0"/>
+          <a:ext cx="0" cy="0"/>
+          <a:chOff x="0" y="0"/>
+          <a:chExt cx="0" cy="0"/>
+        </a:xfrm>
+      </p:grpSpPr>
       <p:sp>
         <p:nvSpPr>
           <p:cNvPr id="2" name="Rectangle 1"/>
@@ -8216,6 +8294,7 @@
           <a:lstStyle/>
           <a:p>
             <a:pPr algn="ctr"/>
+            <a:endParaRPr/>
           </a:p>
         </p:txBody>
       </p:sp>
@@ -8236,7 +8315,7 @@
           <a:noFill/>
         </p:spPr>
         <p:txBody>
-          <a:bodyPr wrap="square" anchor="t" lIns="0" rIns="0" tIns="0" bIns="0">
+          <a:bodyPr wrap="square" lIns="0" tIns="0" rIns="0" bIns="0" anchor="t">
             <a:spAutoFit/>
           </a:bodyPr>
           <a:lstStyle/>
@@ -8300,7 +8379,7 @@
 </file>
 
 <file path=ppt/slides/slide2.xml><?xml version="1.0" encoding="utf-8"?>
-<p:sld xmlns:a="http://schemas.openxmlformats.org/drawingml/2006/main" xmlns:p="http://schemas.openxmlformats.org/presentationml/2006/main" xmlns:r="http://schemas.openxmlformats.org/officeDocument/2006/relationships">
+<p:sld xmlns:a="http://schemas.openxmlformats.org/drawingml/2006/main" xmlns:r="http://schemas.openxmlformats.org/officeDocument/2006/relationships" xmlns:p="http://schemas.openxmlformats.org/presentationml/2006/main">
   <p:cSld>
     <p:bg>
       <p:bgPr>
@@ -8316,7 +8395,14 @@
         <p:cNvGrpSpPr/>
         <p:nvPr/>
       </p:nvGrpSpPr>
-      <p:grpSpPr/>
+      <p:grpSpPr>
+        <a:xfrm>
+          <a:off x="0" y="0"/>
+          <a:ext cx="0" cy="0"/>
+          <a:chOff x="0" y="0"/>
+          <a:chExt cx="0" cy="0"/>
+        </a:xfrm>
+      </p:grpSpPr>
       <p:sp>
         <p:nvSpPr>
           <p:cNvPr id="2" name="TextBox 1"/>
@@ -8334,7 +8420,7 @@
           <a:noFill/>
         </p:spPr>
         <p:txBody>
-          <a:bodyPr wrap="square" anchor="t" lIns="0" rIns="0" tIns="0" bIns="0">
+          <a:bodyPr wrap="square" lIns="0" tIns="0" rIns="0" bIns="0" anchor="t">
             <a:spAutoFit/>
           </a:bodyPr>
           <a:lstStyle/>
@@ -8392,6 +8478,7 @@
           <a:lstStyle/>
           <a:p>
             <a:pPr algn="ctr"/>
+            <a:endParaRPr/>
           </a:p>
         </p:txBody>
       </p:sp>
@@ -8412,7 +8499,7 @@
           <a:noFill/>
         </p:spPr>
         <p:txBody>
-          <a:bodyPr wrap="square" anchor="t" lIns="0" rIns="0" tIns="0" bIns="0">
+          <a:bodyPr wrap="square" lIns="0" tIns="0" rIns="0" bIns="0" anchor="t">
             <a:spAutoFit/>
           </a:bodyPr>
           <a:lstStyle/>
@@ -8551,7 +8638,7 @@
           <p:nvPr/>
         </p:nvPicPr>
         <p:blipFill>
-          <a:blip r:embed="rId2"/>
+          <a:blip r:embed="rId3"/>
           <a:stretch>
             <a:fillRect/>
           </a:stretch>
@@ -8607,6 +8694,7 @@
           <a:lstStyle/>
           <a:p>
             <a:pPr algn="ctr"/>
+            <a:endParaRPr/>
           </a:p>
         </p:txBody>
       </p:sp>
@@ -8627,7 +8715,7 @@
           <a:noFill/>
         </p:spPr>
         <p:txBody>
-          <a:bodyPr wrap="square" anchor="t" lIns="0" rIns="0" tIns="0" bIns="0">
+          <a:bodyPr wrap="square" lIns="0" tIns="0" rIns="0" bIns="0" anchor="t">
             <a:spAutoFit/>
           </a:bodyPr>
           <a:lstStyle/>
@@ -8670,7 +8758,7 @@
           <a:noFill/>
         </p:spPr>
         <p:txBody>
-          <a:bodyPr wrap="square" anchor="t" lIns="0" rIns="0" tIns="0" bIns="0">
+          <a:bodyPr wrap="square" lIns="0" tIns="0" rIns="0" bIns="0" anchor="t">
             <a:spAutoFit/>
           </a:bodyPr>
           <a:lstStyle/>
@@ -8697,7 +8785,7 @@
 </file>
 
 <file path=ppt/slides/slide3.xml><?xml version="1.0" encoding="utf-8"?>
-<p:sld xmlns:a="http://schemas.openxmlformats.org/drawingml/2006/main" xmlns:p="http://schemas.openxmlformats.org/presentationml/2006/main" xmlns:r="http://schemas.openxmlformats.org/officeDocument/2006/relationships">
+<p:sld xmlns:a="http://schemas.openxmlformats.org/drawingml/2006/main" xmlns:r="http://schemas.openxmlformats.org/officeDocument/2006/relationships" xmlns:p="http://schemas.openxmlformats.org/presentationml/2006/main">
   <p:cSld>
     <p:bg>
       <p:bgPr>
@@ -8713,7 +8801,14 @@
         <p:cNvGrpSpPr/>
         <p:nvPr/>
       </p:nvGrpSpPr>
-      <p:grpSpPr/>
+      <p:grpSpPr>
+        <a:xfrm>
+          <a:off x="0" y="0"/>
+          <a:ext cx="0" cy="0"/>
+          <a:chOff x="0" y="0"/>
+          <a:chExt cx="0" cy="0"/>
+        </a:xfrm>
+      </p:grpSpPr>
       <p:sp>
         <p:nvSpPr>
           <p:cNvPr id="2" name="Rectangle 1"/>
@@ -8755,6 +8850,7 @@
           <a:lstStyle/>
           <a:p>
             <a:pPr algn="ctr"/>
+            <a:endParaRPr/>
           </a:p>
         </p:txBody>
       </p:sp>
@@ -8775,7 +8871,7 @@
           <a:noFill/>
         </p:spPr>
         <p:txBody>
-          <a:bodyPr wrap="square" anchor="t" lIns="0" rIns="0" tIns="0" bIns="0">
+          <a:bodyPr wrap="square" lIns="0" tIns="0" rIns="0" bIns="0" anchor="t">
             <a:spAutoFit/>
           </a:bodyPr>
           <a:lstStyle/>
@@ -8809,7 +8905,7 @@
           <a:noFill/>
         </p:spPr>
         <p:txBody>
-          <a:bodyPr wrap="square" anchor="t" lIns="0" rIns="0" tIns="0" bIns="0">
+          <a:bodyPr wrap="square" lIns="0" tIns="0" rIns="0" bIns="0" anchor="t">
             <a:spAutoFit/>
           </a:bodyPr>
           <a:lstStyle/>
@@ -8899,6 +8995,7 @@
           <a:lstStyle/>
           <a:p>
             <a:pPr algn="ctr"/>
+            <a:endParaRPr/>
           </a:p>
         </p:txBody>
       </p:sp>
@@ -8919,7 +9016,7 @@
           <a:noFill/>
         </p:spPr>
         <p:txBody>
-          <a:bodyPr wrap="square" anchor="t" lIns="0" rIns="0" tIns="0" bIns="0">
+          <a:bodyPr wrap="square" lIns="0" tIns="0" rIns="0" bIns="0" anchor="t">
             <a:spAutoFit/>
           </a:bodyPr>
           <a:lstStyle/>
@@ -8962,21 +9059,13 @@
           <a:noFill/>
         </p:spPr>
         <p:txBody>
-          <a:bodyPr wrap="square" anchor="t" lIns="0" rIns="0" tIns="0" bIns="0">
+          <a:bodyPr wrap="square" lIns="0" tIns="0" rIns="0" bIns="0" anchor="t">
             <a:spAutoFit/>
           </a:bodyPr>
           <a:lstStyle/>
           <a:p>
             <a:pPr algn="r"/>
-            <a:r>
-              <a:rPr sz="1100" b="0" i="0">
-                <a:solidFill>
-                  <a:srgbClr val="7A7A7A"/>
-                </a:solidFill>
-                <a:latin typeface="Roboto"/>
-              </a:rPr>
-              <a:t/>
-            </a:r>
+            <a:endParaRPr/>
           </a:p>
         </p:txBody>
       </p:sp>
@@ -8989,7 +9078,7 @@
 </file>
 
 <file path=ppt/slides/slide4.xml><?xml version="1.0" encoding="utf-8"?>
-<p:sld xmlns:a="http://schemas.openxmlformats.org/drawingml/2006/main" xmlns:p="http://schemas.openxmlformats.org/presentationml/2006/main" xmlns:r="http://schemas.openxmlformats.org/officeDocument/2006/relationships">
+<p:sld xmlns:a="http://schemas.openxmlformats.org/drawingml/2006/main" xmlns:r="http://schemas.openxmlformats.org/officeDocument/2006/relationships" xmlns:p="http://schemas.openxmlformats.org/presentationml/2006/main">
   <p:cSld>
     <p:bg>
       <p:bgPr>
@@ -9005,7 +9094,14 @@
         <p:cNvGrpSpPr/>
         <p:nvPr/>
       </p:nvGrpSpPr>
-      <p:grpSpPr/>
+      <p:grpSpPr>
+        <a:xfrm>
+          <a:off x="0" y="0"/>
+          <a:ext cx="0" cy="0"/>
+          <a:chOff x="0" y="0"/>
+          <a:chExt cx="0" cy="0"/>
+        </a:xfrm>
+      </p:grpSpPr>
       <p:sp>
         <p:nvSpPr>
           <p:cNvPr id="2" name="TextBox 1"/>
@@ -9023,7 +9119,7 @@
           <a:noFill/>
         </p:spPr>
         <p:txBody>
-          <a:bodyPr wrap="square" anchor="t" lIns="0" rIns="0" tIns="0" bIns="0">
+          <a:bodyPr wrap="square" lIns="0" tIns="0" rIns="0" bIns="0" anchor="t">
             <a:spAutoFit/>
           </a:bodyPr>
           <a:lstStyle/>
@@ -9081,6 +9177,7 @@
           <a:lstStyle/>
           <a:p>
             <a:pPr algn="ctr"/>
+            <a:endParaRPr/>
           </a:p>
         </p:txBody>
       </p:sp>
@@ -9101,7 +9198,7 @@
           <a:noFill/>
         </p:spPr>
         <p:txBody>
-          <a:bodyPr wrap="square" anchor="ctr" lIns="0" rIns="0" tIns="0" bIns="0">
+          <a:bodyPr wrap="square" lIns="0" tIns="0" rIns="0" bIns="0" anchor="ctr">
             <a:spAutoFit/>
           </a:bodyPr>
           <a:lstStyle/>
@@ -9241,6 +9338,7 @@
           <a:lstStyle/>
           <a:p>
             <a:pPr algn="ctr"/>
+            <a:endParaRPr/>
           </a:p>
         </p:txBody>
       </p:sp>
@@ -9261,7 +9359,7 @@
           <a:noFill/>
         </p:spPr>
         <p:txBody>
-          <a:bodyPr wrap="square" anchor="t" lIns="0" rIns="0" tIns="0" bIns="0">
+          <a:bodyPr wrap="square" lIns="0" tIns="0" rIns="0" bIns="0" anchor="t">
             <a:spAutoFit/>
           </a:bodyPr>
           <a:lstStyle/>
@@ -9304,7 +9402,7 @@
           <a:noFill/>
         </p:spPr>
         <p:txBody>
-          <a:bodyPr wrap="square" anchor="t" lIns="0" rIns="0" tIns="0" bIns="0">
+          <a:bodyPr wrap="square" lIns="0" tIns="0" rIns="0" bIns="0" anchor="t">
             <a:spAutoFit/>
           </a:bodyPr>
           <a:lstStyle/>
@@ -9331,7 +9429,7 @@
 </file>
 
 <file path=ppt/slides/slide5.xml><?xml version="1.0" encoding="utf-8"?>
-<p:sld xmlns:a="http://schemas.openxmlformats.org/drawingml/2006/main" xmlns:p="http://schemas.openxmlformats.org/presentationml/2006/main" xmlns:r="http://schemas.openxmlformats.org/officeDocument/2006/relationships">
+<p:sld xmlns:a="http://schemas.openxmlformats.org/drawingml/2006/main" xmlns:r="http://schemas.openxmlformats.org/officeDocument/2006/relationships" xmlns:p="http://schemas.openxmlformats.org/presentationml/2006/main">
   <p:cSld>
     <p:bg>
       <p:bgPr>
@@ -9347,7 +9445,38 @@
         <p:cNvGrpSpPr/>
         <p:nvPr/>
       </p:nvGrpSpPr>
-      <p:grpSpPr/>
+      <p:grpSpPr>
+        <a:xfrm>
+          <a:off x="0" y="0"/>
+          <a:ext cx="0" cy="0"/>
+          <a:chOff x="0" y="0"/>
+          <a:chExt cx="0" cy="0"/>
+        </a:xfrm>
+      </p:grpSpPr>
+      <p:pic>
+        <p:nvPicPr>
+          <p:cNvPr id="5" name="Picture 4" descr="ledgerline-baseline.png"/>
+          <p:cNvPicPr>
+            <a:picLocks noChangeAspect="1"/>
+          </p:cNvPicPr>
+          <p:nvPr/>
+        </p:nvPicPr>
+        <p:blipFill>
+          <a:blip r:embed="rId3"/>
+          <a:stretch>
+            <a:fillRect/>
+          </a:stretch>
+        </p:blipFill>
+        <p:spPr>
+          <a:xfrm>
+            <a:off x="4931229" y="1060191"/>
+            <a:ext cx="6590211" cy="4471929"/>
+          </a:xfrm>
+          <a:prstGeom prst="rect">
+            <a:avLst/>
+          </a:prstGeom>
+        </p:spPr>
+      </p:pic>
       <p:sp>
         <p:nvSpPr>
           <p:cNvPr id="2" name="TextBox 1"/>
@@ -9365,7 +9494,7 @@
           <a:noFill/>
         </p:spPr>
         <p:txBody>
-          <a:bodyPr wrap="square" anchor="t" lIns="0" rIns="0" tIns="0" bIns="0">
+          <a:bodyPr wrap="square" lIns="0" tIns="0" rIns="0" bIns="0" anchor="t">
             <a:spAutoFit/>
           </a:bodyPr>
           <a:lstStyle/>
@@ -9423,6 +9552,7 @@
           <a:lstStyle/>
           <a:p>
             <a:pPr algn="ctr"/>
+            <a:endParaRPr/>
           </a:p>
         </p:txBody>
       </p:sp>
@@ -9443,7 +9573,7 @@
           <a:noFill/>
         </p:spPr>
         <p:txBody>
-          <a:bodyPr wrap="square" anchor="t" lIns="0" rIns="0" tIns="0" bIns="0">
+          <a:bodyPr wrap="square" lIns="0" tIns="0" rIns="0" bIns="0" anchor="t">
             <a:spAutoFit/>
           </a:bodyPr>
           <a:lstStyle/>
@@ -9542,30 +9672,6 @@
           </a:p>
         </p:txBody>
       </p:sp>
-      <p:pic>
-        <p:nvPicPr>
-          <p:cNvPr id="5" name="Picture 4" descr="ledgerline-baseline.png"/>
-          <p:cNvPicPr>
-            <a:picLocks noChangeAspect="1"/>
-          </p:cNvPicPr>
-          <p:nvPr/>
-        </p:nvPicPr>
-        <p:blipFill>
-          <a:blip r:embed="rId2"/>
-          <a:stretch>
-            <a:fillRect/>
-          </a:stretch>
-        </p:blipFill>
-        <p:spPr>
-          <a:xfrm>
-            <a:off x="6400800" y="2057400"/>
-            <a:ext cx="5120640" cy="3474720"/>
-          </a:xfrm>
-          <a:prstGeom prst="rect">
-            <a:avLst/>
-          </a:prstGeom>
-        </p:spPr>
-      </p:pic>
       <p:sp>
         <p:nvSpPr>
           <p:cNvPr id="6" name="Rectangle 5"/>
@@ -9607,6 +9713,7 @@
           <a:lstStyle/>
           <a:p>
             <a:pPr algn="ctr"/>
+            <a:endParaRPr/>
           </a:p>
         </p:txBody>
       </p:sp>
@@ -9627,7 +9734,7 @@
           <a:noFill/>
         </p:spPr>
         <p:txBody>
-          <a:bodyPr wrap="square" anchor="t" lIns="0" rIns="0" tIns="0" bIns="0">
+          <a:bodyPr wrap="square" lIns="0" tIns="0" rIns="0" bIns="0" anchor="t">
             <a:spAutoFit/>
           </a:bodyPr>
           <a:lstStyle/>
@@ -9670,7 +9777,7 @@
           <a:noFill/>
         </p:spPr>
         <p:txBody>
-          <a:bodyPr wrap="square" anchor="t" lIns="0" rIns="0" tIns="0" bIns="0">
+          <a:bodyPr wrap="square" lIns="0" tIns="0" rIns="0" bIns="0" anchor="t">
             <a:spAutoFit/>
           </a:bodyPr>
           <a:lstStyle/>
@@ -9697,7 +9804,7 @@
 </file>
 
 <file path=ppt/slides/slide6.xml><?xml version="1.0" encoding="utf-8"?>
-<p:sld xmlns:a="http://schemas.openxmlformats.org/drawingml/2006/main" xmlns:p="http://schemas.openxmlformats.org/presentationml/2006/main" xmlns:r="http://schemas.openxmlformats.org/officeDocument/2006/relationships">
+<p:sld xmlns:a="http://schemas.openxmlformats.org/drawingml/2006/main" xmlns:r="http://schemas.openxmlformats.org/officeDocument/2006/relationships" xmlns:p="http://schemas.openxmlformats.org/presentationml/2006/main">
   <p:cSld>
     <p:bg>
       <p:bgPr>
@@ -9713,7 +9820,14 @@
         <p:cNvGrpSpPr/>
         <p:nvPr/>
       </p:nvGrpSpPr>
-      <p:grpSpPr/>
+      <p:grpSpPr>
+        <a:xfrm>
+          <a:off x="0" y="0"/>
+          <a:ext cx="0" cy="0"/>
+          <a:chOff x="0" y="0"/>
+          <a:chExt cx="0" cy="0"/>
+        </a:xfrm>
+      </p:grpSpPr>
       <p:sp>
         <p:nvSpPr>
           <p:cNvPr id="2" name="TextBox 1"/>
@@ -9731,7 +9845,7 @@
           <a:noFill/>
         </p:spPr>
         <p:txBody>
-          <a:bodyPr wrap="square" anchor="t" lIns="0" rIns="0" tIns="0" bIns="0">
+          <a:bodyPr wrap="square" lIns="0" tIns="0" rIns="0" bIns="0" anchor="t">
             <a:spAutoFit/>
           </a:bodyPr>
           <a:lstStyle/>
@@ -9789,6 +9903,7 @@
           <a:lstStyle/>
           <a:p>
             <a:pPr algn="ctr"/>
+            <a:endParaRPr/>
           </a:p>
         </p:txBody>
       </p:sp>
@@ -9809,7 +9924,7 @@
           <a:noFill/>
         </p:spPr>
         <p:txBody>
-          <a:bodyPr wrap="square" anchor="ctr" lIns="0" rIns="0" tIns="0" bIns="0">
+          <a:bodyPr wrap="square" lIns="0" tIns="0" rIns="0" bIns="0" anchor="ctr">
             <a:spAutoFit/>
           </a:bodyPr>
           <a:lstStyle/>
@@ -9949,6 +10064,7 @@
           <a:lstStyle/>
           <a:p>
             <a:pPr algn="ctr"/>
+            <a:endParaRPr/>
           </a:p>
         </p:txBody>
       </p:sp>
@@ -9969,7 +10085,7 @@
           <a:noFill/>
         </p:spPr>
         <p:txBody>
-          <a:bodyPr wrap="square" anchor="t" lIns="0" rIns="0" tIns="0" bIns="0">
+          <a:bodyPr wrap="square" lIns="0" tIns="0" rIns="0" bIns="0" anchor="t">
             <a:spAutoFit/>
           </a:bodyPr>
           <a:lstStyle/>
@@ -10012,7 +10128,7 @@
           <a:noFill/>
         </p:spPr>
         <p:txBody>
-          <a:bodyPr wrap="square" anchor="t" lIns="0" rIns="0" tIns="0" bIns="0">
+          <a:bodyPr wrap="square" lIns="0" tIns="0" rIns="0" bIns="0" anchor="t">
             <a:spAutoFit/>
           </a:bodyPr>
           <a:lstStyle/>
@@ -10039,7 +10155,7 @@
 </file>
 
 <file path=ppt/slides/slide7.xml><?xml version="1.0" encoding="utf-8"?>
-<p:sld xmlns:a="http://schemas.openxmlformats.org/drawingml/2006/main" xmlns:p="http://schemas.openxmlformats.org/presentationml/2006/main" xmlns:r="http://schemas.openxmlformats.org/officeDocument/2006/relationships">
+<p:sld xmlns:a="http://schemas.openxmlformats.org/drawingml/2006/main" xmlns:r="http://schemas.openxmlformats.org/officeDocument/2006/relationships" xmlns:p="http://schemas.openxmlformats.org/presentationml/2006/main">
   <p:cSld>
     <p:bg>
       <p:bgPr>
@@ -10055,7 +10171,14 @@
         <p:cNvGrpSpPr/>
         <p:nvPr/>
       </p:nvGrpSpPr>
-      <p:grpSpPr/>
+      <p:grpSpPr>
+        <a:xfrm>
+          <a:off x="0" y="0"/>
+          <a:ext cx="0" cy="0"/>
+          <a:chOff x="0" y="0"/>
+          <a:chExt cx="0" cy="0"/>
+        </a:xfrm>
+      </p:grpSpPr>
       <p:sp>
         <p:nvSpPr>
           <p:cNvPr id="2" name="Rectangle 1"/>
@@ -10097,6 +10220,7 @@
           <a:lstStyle/>
           <a:p>
             <a:pPr algn="ctr"/>
+            <a:endParaRPr/>
           </a:p>
         </p:txBody>
       </p:sp>
@@ -10170,7 +10294,7 @@
           <a:noFill/>
         </p:spPr>
         <p:txBody>
-          <a:bodyPr wrap="square" anchor="ctr" lIns="0" rIns="0" tIns="0" bIns="0">
+          <a:bodyPr wrap="square" lIns="0" tIns="0" rIns="0" bIns="0" anchor="ctr">
             <a:spAutoFit/>
           </a:bodyPr>
           <a:lstStyle/>
@@ -10204,7 +10328,7 @@
           <a:noFill/>
         </p:spPr>
         <p:txBody>
-          <a:bodyPr wrap="square" anchor="t" lIns="0" rIns="0" tIns="0" bIns="0">
+          <a:bodyPr wrap="square" lIns="0" tIns="0" rIns="0" bIns="0" anchor="t">
             <a:spAutoFit/>
           </a:bodyPr>
           <a:lstStyle/>
@@ -10315,6 +10439,7 @@
           <a:lstStyle/>
           <a:p>
             <a:pPr algn="ctr"/>
+            <a:endParaRPr/>
           </a:p>
         </p:txBody>
       </p:sp>
@@ -10335,7 +10460,7 @@
           <a:noFill/>
         </p:spPr>
         <p:txBody>
-          <a:bodyPr wrap="square" anchor="ctr" lIns="0" rIns="0" tIns="0" bIns="0">
+          <a:bodyPr wrap="square" lIns="0" tIns="0" rIns="0" bIns="0" anchor="ctr">
             <a:spAutoFit/>
           </a:bodyPr>
           <a:lstStyle/>
@@ -10393,6 +10518,7 @@
           <a:lstStyle/>
           <a:p>
             <a:pPr algn="ctr"/>
+            <a:endParaRPr/>
           </a:p>
         </p:txBody>
       </p:sp>
@@ -10413,7 +10539,7 @@
           <a:noFill/>
         </p:spPr>
         <p:txBody>
-          <a:bodyPr wrap="square" anchor="t" lIns="0" rIns="0" tIns="0" bIns="0">
+          <a:bodyPr wrap="square" lIns="0" tIns="0" rIns="0" bIns="0" anchor="t">
             <a:spAutoFit/>
           </a:bodyPr>
           <a:lstStyle/>
@@ -10456,7 +10582,7 @@
           <a:noFill/>
         </p:spPr>
         <p:txBody>
-          <a:bodyPr wrap="square" anchor="t" lIns="0" rIns="0" tIns="0" bIns="0">
+          <a:bodyPr wrap="square" lIns="0" tIns="0" rIns="0" bIns="0" anchor="t">
             <a:spAutoFit/>
           </a:bodyPr>
           <a:lstStyle/>
@@ -10483,7 +10609,7 @@
 </file>
 
 <file path=ppt/slides/slide8.xml><?xml version="1.0" encoding="utf-8"?>
-<p:sld xmlns:a="http://schemas.openxmlformats.org/drawingml/2006/main" xmlns:p="http://schemas.openxmlformats.org/presentationml/2006/main" xmlns:r="http://schemas.openxmlformats.org/officeDocument/2006/relationships">
+<p:sld xmlns:a="http://schemas.openxmlformats.org/drawingml/2006/main" xmlns:r="http://schemas.openxmlformats.org/officeDocument/2006/relationships" xmlns:p="http://schemas.openxmlformats.org/presentationml/2006/main">
   <p:cSld>
     <p:bg>
       <p:bgPr>
@@ -10499,7 +10625,14 @@
         <p:cNvGrpSpPr/>
         <p:nvPr/>
       </p:nvGrpSpPr>
-      <p:grpSpPr/>
+      <p:grpSpPr>
+        <a:xfrm>
+          <a:off x="0" y="0"/>
+          <a:ext cx="0" cy="0"/>
+          <a:chOff x="0" y="0"/>
+          <a:chExt cx="0" cy="0"/>
+        </a:xfrm>
+      </p:grpSpPr>
       <p:sp>
         <p:nvSpPr>
           <p:cNvPr id="2" name="Rectangle 1"/>
@@ -10541,6 +10674,7 @@
           <a:lstStyle/>
           <a:p>
             <a:pPr algn="ctr"/>
+            <a:endParaRPr/>
           </a:p>
         </p:txBody>
       </p:sp>
@@ -10561,7 +10695,7 @@
           <a:noFill/>
         </p:spPr>
         <p:txBody>
-          <a:bodyPr wrap="square" anchor="t" lIns="0" rIns="0" tIns="0" bIns="0">
+          <a:bodyPr wrap="square" lIns="0" tIns="0" rIns="0" bIns="0" anchor="t">
             <a:spAutoFit/>
           </a:bodyPr>
           <a:lstStyle/>
@@ -10595,7 +10729,7 @@
           <a:noFill/>
         </p:spPr>
         <p:txBody>
-          <a:bodyPr wrap="square" anchor="t" lIns="0" rIns="0" tIns="0" bIns="0">
+          <a:bodyPr wrap="square" lIns="0" tIns="0" rIns="0" bIns="0" anchor="t">
             <a:spAutoFit/>
           </a:bodyPr>
           <a:lstStyle/>
@@ -10685,6 +10819,7 @@
           <a:lstStyle/>
           <a:p>
             <a:pPr algn="ctr"/>
+            <a:endParaRPr/>
           </a:p>
         </p:txBody>
       </p:sp>
@@ -10705,7 +10840,7 @@
           <a:noFill/>
         </p:spPr>
         <p:txBody>
-          <a:bodyPr wrap="square" anchor="t" lIns="0" rIns="0" tIns="0" bIns="0">
+          <a:bodyPr wrap="square" lIns="0" tIns="0" rIns="0" bIns="0" anchor="t">
             <a:spAutoFit/>
           </a:bodyPr>
           <a:lstStyle/>
@@ -10748,21 +10883,13 @@
           <a:noFill/>
         </p:spPr>
         <p:txBody>
-          <a:bodyPr wrap="square" anchor="t" lIns="0" rIns="0" tIns="0" bIns="0">
+          <a:bodyPr wrap="square" lIns="0" tIns="0" rIns="0" bIns="0" anchor="t">
             <a:spAutoFit/>
           </a:bodyPr>
           <a:lstStyle/>
           <a:p>
             <a:pPr algn="r"/>
-            <a:r>
-              <a:rPr sz="1100" b="0" i="0">
-                <a:solidFill>
-                  <a:srgbClr val="7A7A7A"/>
-                </a:solidFill>
-                <a:latin typeface="Roboto"/>
-              </a:rPr>
-              <a:t/>
-            </a:r>
+            <a:endParaRPr/>
           </a:p>
         </p:txBody>
       </p:sp>
@@ -10775,7 +10902,7 @@
 </file>
 
 <file path=ppt/slides/slide9.xml><?xml version="1.0" encoding="utf-8"?>
-<p:sld xmlns:a="http://schemas.openxmlformats.org/drawingml/2006/main" xmlns:p="http://schemas.openxmlformats.org/presentationml/2006/main" xmlns:r="http://schemas.openxmlformats.org/officeDocument/2006/relationships">
+<p:sld xmlns:a="http://schemas.openxmlformats.org/drawingml/2006/main" xmlns:r="http://schemas.openxmlformats.org/officeDocument/2006/relationships" xmlns:p="http://schemas.openxmlformats.org/presentationml/2006/main">
   <p:cSld>
     <p:bg>
       <p:bgPr>
@@ -10791,7 +10918,14 @@
         <p:cNvGrpSpPr/>
         <p:nvPr/>
       </p:nvGrpSpPr>
-      <p:grpSpPr/>
+      <p:grpSpPr>
+        <a:xfrm>
+          <a:off x="0" y="0"/>
+          <a:ext cx="0" cy="0"/>
+          <a:chOff x="0" y="0"/>
+          <a:chExt cx="0" cy="0"/>
+        </a:xfrm>
+      </p:grpSpPr>
       <p:sp>
         <p:nvSpPr>
           <p:cNvPr id="2" name="TextBox 1"/>
@@ -10809,7 +10943,7 @@
           <a:noFill/>
         </p:spPr>
         <p:txBody>
-          <a:bodyPr wrap="square" anchor="t" lIns="0" rIns="0" tIns="0" bIns="0">
+          <a:bodyPr wrap="square" lIns="0" tIns="0" rIns="0" bIns="0" anchor="t">
             <a:spAutoFit/>
           </a:bodyPr>
           <a:lstStyle/>
@@ -10867,6 +11001,7 @@
           <a:lstStyle/>
           <a:p>
             <a:pPr algn="ctr"/>
+            <a:endParaRPr/>
           </a:p>
         </p:txBody>
       </p:sp>
@@ -10887,7 +11022,7 @@
           <a:noFill/>
         </p:spPr>
         <p:txBody>
-          <a:bodyPr wrap="square" anchor="ctr" lIns="0" rIns="0" tIns="0" bIns="0">
+          <a:bodyPr wrap="square" lIns="0" tIns="0" rIns="0" bIns="0" anchor="ctr">
             <a:spAutoFit/>
           </a:bodyPr>
           <a:lstStyle/>
@@ -11027,6 +11162,7 @@
           <a:lstStyle/>
           <a:p>
             <a:pPr algn="ctr"/>
+            <a:endParaRPr/>
           </a:p>
         </p:txBody>
       </p:sp>
@@ -11047,7 +11183,7 @@
           <a:noFill/>
         </p:spPr>
         <p:txBody>
-          <a:bodyPr wrap="square" anchor="t" lIns="0" rIns="0" tIns="0" bIns="0">
+          <a:bodyPr wrap="square" lIns="0" tIns="0" rIns="0" bIns="0" anchor="t">
             <a:spAutoFit/>
           </a:bodyPr>
           <a:lstStyle/>
@@ -11090,7 +11226,7 @@
           <a:noFill/>
         </p:spPr>
         <p:txBody>
-          <a:bodyPr wrap="square" anchor="t" lIns="0" rIns="0" tIns="0" bIns="0">
+          <a:bodyPr wrap="square" lIns="0" tIns="0" rIns="0" bIns="0" anchor="t">
             <a:spAutoFit/>
           </a:bodyPr>
           <a:lstStyle/>
@@ -11447,44 +11583,44 @@
         <a:sysClr val="window" lastClr="FFFFFF"/>
       </a:lt1>
       <a:dk2>
-        <a:srgbClr val="1F497D"/>
+        <a:srgbClr val="0E2841"/>
       </a:dk2>
       <a:lt2>
-        <a:srgbClr val="EEECE1"/>
+        <a:srgbClr val="E8E8E8"/>
       </a:lt2>
       <a:accent1>
-        <a:srgbClr val="4F81BD"/>
+        <a:srgbClr val="156082"/>
       </a:accent1>
       <a:accent2>
-        <a:srgbClr val="C0504D"/>
+        <a:srgbClr val="E97132"/>
       </a:accent2>
       <a:accent3>
-        <a:srgbClr val="9BBB59"/>
+        <a:srgbClr val="196B24"/>
       </a:accent3>
       <a:accent4>
-        <a:srgbClr val="8064A2"/>
+        <a:srgbClr val="0F9ED5"/>
       </a:accent4>
       <a:accent5>
-        <a:srgbClr val="4BACC6"/>
+        <a:srgbClr val="A02B93"/>
       </a:accent5>
       <a:accent6>
-        <a:srgbClr val="F79646"/>
+        <a:srgbClr val="4EA72E"/>
       </a:accent6>
       <a:hlink>
-        <a:srgbClr val="0000FF"/>
+        <a:srgbClr val="467886"/>
       </a:hlink>
       <a:folHlink>
-        <a:srgbClr val="800080"/>
+        <a:srgbClr val="96607D"/>
       </a:folHlink>
     </a:clrScheme>
     <a:fontScheme name="Office">
       <a:majorFont>
-        <a:latin typeface="Calibri"/>
+        <a:latin typeface="Aptos Display" panose="02110004020202020204"/>
         <a:ea typeface=""/>
         <a:cs typeface=""/>
-        <a:font script="Jpan" typeface="ＭＳ Ｐゴシック"/>
+        <a:font script="Jpan" typeface="游ゴシック Light"/>
         <a:font script="Hang" typeface="맑은 고딕"/>
-        <a:font script="Hans" typeface="宋体"/>
+        <a:font script="Hans" typeface="等线 Light"/>
         <a:font script="Hant" typeface="新細明體"/>
         <a:font script="Arab" typeface="Times New Roman"/>
         <a:font script="Hebr" typeface="Times New Roman"/>
@@ -11512,14 +11648,31 @@
         <a:font script="Viet" typeface="Times New Roman"/>
         <a:font script="Uigh" typeface="Microsoft Uighur"/>
         <a:font script="Geor" typeface="Sylfaen"/>
+        <a:font script="Armn" typeface="Arial"/>
+        <a:font script="Bugi" typeface="Leelawadee UI"/>
+        <a:font script="Bopo" typeface="Microsoft JhengHei"/>
+        <a:font script="Java" typeface="Javanese Text"/>
+        <a:font script="Lisu" typeface="Segoe UI"/>
+        <a:font script="Mymr" typeface="Myanmar Text"/>
+        <a:font script="Nkoo" typeface="Ebrima"/>
+        <a:font script="Olck" typeface="Nirmala UI"/>
+        <a:font script="Osma" typeface="Ebrima"/>
+        <a:font script="Phag" typeface="Phagspa"/>
+        <a:font script="Syrn" typeface="Estrangelo Edessa"/>
+        <a:font script="Syrj" typeface="Estrangelo Edessa"/>
+        <a:font script="Syre" typeface="Estrangelo Edessa"/>
+        <a:font script="Sora" typeface="Nirmala UI"/>
+        <a:font script="Tale" typeface="Microsoft Tai Le"/>
+        <a:font script="Talu" typeface="Microsoft New Tai Lue"/>
+        <a:font script="Tfng" typeface="Ebrima"/>
       </a:majorFont>
       <a:minorFont>
-        <a:latin typeface="Calibri"/>
+        <a:latin typeface="Aptos" panose="02110004020202020204"/>
         <a:ea typeface=""/>
         <a:cs typeface=""/>
-        <a:font script="Jpan" typeface="ＭＳ Ｐゴシック"/>
+        <a:font script="Jpan" typeface="游ゴシック"/>
         <a:font script="Hang" typeface="맑은 고딕"/>
-        <a:font script="Hans" typeface="宋体"/>
+        <a:font script="Hans" typeface="等线"/>
         <a:font script="Hant" typeface="新細明體"/>
         <a:font script="Arab" typeface="Arial"/>
         <a:font script="Hebr" typeface="Arial"/>
@@ -11547,6 +11700,23 @@
         <a:font script="Viet" typeface="Arial"/>
         <a:font script="Uigh" typeface="Microsoft Uighur"/>
         <a:font script="Geor" typeface="Sylfaen"/>
+        <a:font script="Armn" typeface="Arial"/>
+        <a:font script="Bugi" typeface="Leelawadee UI"/>
+        <a:font script="Bopo" typeface="Microsoft JhengHei"/>
+        <a:font script="Java" typeface="Javanese Text"/>
+        <a:font script="Lisu" typeface="Segoe UI"/>
+        <a:font script="Mymr" typeface="Myanmar Text"/>
+        <a:font script="Nkoo" typeface="Ebrima"/>
+        <a:font script="Olck" typeface="Nirmala UI"/>
+        <a:font script="Osma" typeface="Ebrima"/>
+        <a:font script="Phag" typeface="Phagspa"/>
+        <a:font script="Syrn" typeface="Estrangelo Edessa"/>
+        <a:font script="Syrj" typeface="Estrangelo Edessa"/>
+        <a:font script="Syre" typeface="Estrangelo Edessa"/>
+        <a:font script="Sora" typeface="Nirmala UI"/>
+        <a:font script="Tale" typeface="Microsoft Tai Le"/>
+        <a:font script="Talu" typeface="Microsoft New Tai Lue"/>
+        <a:font script="Tfng" typeface="Ebrima"/>
       </a:minorFont>
     </a:fontScheme>
     <a:fmtScheme name="Office">
@@ -11558,180 +11728,136 @@
           <a:gsLst>
             <a:gs pos="0">
               <a:schemeClr val="phClr">
-                <a:tint val="50000"/>
-                <a:satMod val="300000"/>
+                <a:lumMod val="110000"/>
+                <a:satMod val="105000"/>
+                <a:tint val="67000"/>
               </a:schemeClr>
             </a:gs>
-            <a:gs pos="35000">
+            <a:gs pos="50000">
               <a:schemeClr val="phClr">
-                <a:tint val="37000"/>
-                <a:satMod val="300000"/>
+                <a:lumMod val="105000"/>
+                <a:satMod val="103000"/>
+                <a:tint val="73000"/>
               </a:schemeClr>
             </a:gs>
             <a:gs pos="100000">
               <a:schemeClr val="phClr">
-                <a:tint val="15000"/>
-                <a:satMod val="350000"/>
+                <a:lumMod val="105000"/>
+                <a:satMod val="109000"/>
+                <a:tint val="81000"/>
               </a:schemeClr>
             </a:gs>
           </a:gsLst>
-          <a:lin ang="16200000" scaled="1"/>
+          <a:lin ang="5400000" scaled="0"/>
         </a:gradFill>
         <a:gradFill rotWithShape="1">
           <a:gsLst>
             <a:gs pos="0">
               <a:schemeClr val="phClr">
-                <a:tint val="100000"/>
+                <a:satMod val="103000"/>
+                <a:lumMod val="102000"/>
+                <a:tint val="94000"/>
+              </a:schemeClr>
+            </a:gs>
+            <a:gs pos="50000">
+              <a:schemeClr val="phClr">
+                <a:satMod val="110000"/>
+                <a:lumMod val="100000"/>
                 <a:shade val="100000"/>
-                <a:satMod val="130000"/>
               </a:schemeClr>
             </a:gs>
             <a:gs pos="100000">
               <a:schemeClr val="phClr">
-                <a:tint val="50000"/>
-                <a:shade val="100000"/>
-                <a:satMod val="350000"/>
+                <a:lumMod val="99000"/>
+                <a:satMod val="120000"/>
+                <a:shade val="78000"/>
               </a:schemeClr>
             </a:gs>
           </a:gsLst>
-          <a:lin ang="16200000" scaled="0"/>
+          <a:lin ang="5400000" scaled="0"/>
         </a:gradFill>
       </a:fillStyleLst>
       <a:lnStyleLst>
-        <a:ln w="9525" cap="flat" cmpd="sng" algn="ctr">
+        <a:ln w="12700" cap="flat" cmpd="sng" algn="ctr">
           <a:solidFill>
-            <a:schemeClr val="phClr">
-              <a:shade val="95000"/>
-              <a:satMod val="105000"/>
-            </a:schemeClr>
+            <a:schemeClr val="phClr"/>
           </a:solidFill>
           <a:prstDash val="solid"/>
+          <a:miter lim="800000"/>
+        </a:ln>
+        <a:ln w="19050" cap="flat" cmpd="sng" algn="ctr">
+          <a:solidFill>
+            <a:schemeClr val="phClr"/>
+          </a:solidFill>
+          <a:prstDash val="solid"/>
+          <a:miter lim="800000"/>
         </a:ln>
         <a:ln w="25400" cap="flat" cmpd="sng" algn="ctr">
           <a:solidFill>
             <a:schemeClr val="phClr"/>
           </a:solidFill>
           <a:prstDash val="solid"/>
-        </a:ln>
-        <a:ln w="38100" cap="flat" cmpd="sng" algn="ctr">
-          <a:solidFill>
-            <a:schemeClr val="phClr"/>
-          </a:solidFill>
-          <a:prstDash val="solid"/>
+          <a:miter lim="800000"/>
         </a:ln>
       </a:lnStyleLst>
       <a:effectStyleLst>
         <a:effectStyle>
+          <a:effectLst/>
+        </a:effectStyle>
+        <a:effectStyle>
+          <a:effectLst/>
+        </a:effectStyle>
+        <a:effectStyle>
           <a:effectLst>
-            <a:outerShdw blurRad="40000" dist="20000" dir="5400000" rotWithShape="0">
+            <a:outerShdw blurRad="57150" dist="19050" dir="5400000" algn="ctr" rotWithShape="0">
               <a:srgbClr val="000000">
-                <a:alpha val="38000"/>
+                <a:alpha val="63000"/>
               </a:srgbClr>
             </a:outerShdw>
           </a:effectLst>
-        </a:effectStyle>
-        <a:effectStyle>
-          <a:effectLst>
-            <a:outerShdw blurRad="40000" dist="23000" dir="5400000" rotWithShape="0">
-              <a:srgbClr val="000000">
-                <a:alpha val="35000"/>
-              </a:srgbClr>
-            </a:outerShdw>
-          </a:effectLst>
-        </a:effectStyle>
-        <a:effectStyle>
-          <a:effectLst>
-            <a:outerShdw blurRad="40000" dist="23000" dir="5400000" rotWithShape="0">
-              <a:srgbClr val="000000">
-                <a:alpha val="35000"/>
-              </a:srgbClr>
-            </a:outerShdw>
-          </a:effectLst>
-          <a:scene3d>
-            <a:camera prst="orthographicFront">
-              <a:rot lat="0" lon="0" rev="0"/>
-            </a:camera>
-            <a:lightRig rig="threePt" dir="t">
-              <a:rot lat="0" lon="0" rev="1200000"/>
-            </a:lightRig>
-          </a:scene3d>
-          <a:sp3d>
-            <a:bevelT w="63500" h="25400"/>
-          </a:sp3d>
         </a:effectStyle>
       </a:effectStyleLst>
       <a:bgFillStyleLst>
         <a:solidFill>
           <a:schemeClr val="phClr"/>
         </a:solidFill>
+        <a:solidFill>
+          <a:schemeClr val="phClr">
+            <a:tint val="95000"/>
+            <a:satMod val="170000"/>
+          </a:schemeClr>
+        </a:solidFill>
         <a:gradFill rotWithShape="1">
           <a:gsLst>
             <a:gs pos="0">
               <a:schemeClr val="phClr">
-                <a:tint val="40000"/>
-                <a:satMod val="350000"/>
+                <a:tint val="93000"/>
+                <a:satMod val="150000"/>
+                <a:shade val="98000"/>
+                <a:lumMod val="102000"/>
               </a:schemeClr>
             </a:gs>
-            <a:gs pos="40000">
+            <a:gs pos="50000">
               <a:schemeClr val="phClr">
-                <a:tint val="45000"/>
-                <a:shade val="99000"/>
-                <a:satMod val="350000"/>
+                <a:tint val="98000"/>
+                <a:satMod val="130000"/>
+                <a:shade val="90000"/>
+                <a:lumMod val="103000"/>
               </a:schemeClr>
             </a:gs>
             <a:gs pos="100000">
               <a:schemeClr val="phClr">
-                <a:shade val="20000"/>
-                <a:satMod val="255000"/>
+                <a:shade val="63000"/>
+                <a:satMod val="120000"/>
               </a:schemeClr>
             </a:gs>
           </a:gsLst>
-          <a:path path="circle">
-            <a:fillToRect l="50000" t="-80000" r="50000" b="180000"/>
-          </a:path>
-        </a:gradFill>
-        <a:gradFill rotWithShape="1">
-          <a:gsLst>
-            <a:gs pos="0">
-              <a:schemeClr val="phClr">
-                <a:tint val="80000"/>
-                <a:satMod val="300000"/>
-              </a:schemeClr>
-            </a:gs>
-            <a:gs pos="100000">
-              <a:schemeClr val="phClr">
-                <a:shade val="30000"/>
-                <a:satMod val="200000"/>
-              </a:schemeClr>
-            </a:gs>
-          </a:gsLst>
-          <a:path path="circle">
-            <a:fillToRect l="50000" t="50000" r="50000" b="50000"/>
-          </a:path>
+          <a:lin ang="5400000" scaled="0"/>
         </a:gradFill>
       </a:bgFillStyleLst>
     </a:fmtScheme>
   </a:themeElements>
   <a:objectDefaults>
-    <a:spDef>
-      <a:spPr/>
-      <a:bodyPr/>
-      <a:lstStyle/>
-      <a:style>
-        <a:lnRef idx="1">
-          <a:schemeClr val="accent1"/>
-        </a:lnRef>
-        <a:fillRef idx="3">
-          <a:schemeClr val="accent1"/>
-        </a:fillRef>
-        <a:effectRef idx="2">
-          <a:schemeClr val="accent1"/>
-        </a:effectRef>
-        <a:fontRef idx="minor">
-          <a:schemeClr val="lt1"/>
-        </a:fontRef>
-      </a:style>
-    </a:spDef>
     <a:lnDef>
       <a:spPr/>
       <a:bodyPr/>
@@ -11753,5 +11879,10 @@
     </a:lnDef>
   </a:objectDefaults>
   <a:extraClrSchemeLst/>
+  <a:extLst>
+    <a:ext uri="{05A4C25C-085E-4340-85A3-A5531E510DB2}">
+      <thm15:themeFamily xmlns:thm15="http://schemas.microsoft.com/office/thememl/2012/main" name="Office Theme" id="{2E142A2C-CD16-42D6-873A-C26D2A0506FA}" vid="{1BDDFF52-6CD6-40A5-AB3C-68EB2F1E4D0A}"/>
+    </a:ext>
+  </a:extLst>
 </a:theme>
 </file>
</xml_diff>